<commit_message>
Contexto del cliente en BD II y nube vs on-premise en ARQ
Co-Authored-By: Claude Opus 5 <noreply@anthropic.com>
</commit_message>
<xml_diff>
--- a/Bases de Datos II/Clases/Presentacion del Curso - Bases de Datos II.pptx
+++ b/Bases de Datos II/Clases/Presentacion del Curso - Bases de Datos II.pptx
@@ -19,6 +19,7 @@
     <p:sldId id="267" r:id="rId18"/>
     <p:sldId id="268" r:id="rId19"/>
     <p:sldId id="269" r:id="rId20"/>
+    <p:sldId id="270" r:id="rId21"/>
   </p:sldIdLst>
   <p:sldSz cx="12191695" cy="6858000" type="screen4x3"/>
   <p:notesSz cx="6858000" cy="9144000"/>
@@ -3939,7 +3940,7 @@
         <p:spPr>
           <a:xfrm>
             <a:off x="0" y="0"/>
-            <a:ext cx="12191695" cy="960120"/>
+            <a:ext cx="12191695" cy="1170432"/>
           </a:xfrm>
           <a:prstGeom prst="rect">
             <a:avLst/>
@@ -3981,7 +3982,7 @@
         </p:nvSpPr>
         <p:spPr>
           <a:xfrm>
-            <a:off x="0" y="960120"/>
+            <a:off x="0" y="1170432"/>
             <a:ext cx="12191695" cy="41148"/>
           </a:xfrm>
           <a:prstGeom prst="rect">
@@ -4025,7 +4026,7 @@
         <p:spPr>
           <a:xfrm>
             <a:off x="457200" y="164592"/>
-            <a:ext cx="11277295" cy="502920"/>
+            <a:ext cx="11277295" cy="384048"/>
           </a:xfrm>
           <a:prstGeom prst="rect">
             <a:avLst/>
@@ -4045,7 +4046,7 @@
                 </a:solidFill>
                 <a:latin typeface="Calibri"/>
               </a:rPr>
-              <a:t>Recursos</a:t>
+              <a:t>El cliente · Clínica Veterinaria «Huellitas»</a:t>
             </a:r>
           </a:p>
         </p:txBody>
@@ -4058,8 +4059,42 @@
         </p:nvSpPr>
         <p:spPr>
           <a:xfrm>
-            <a:off x="457200" y="1170432"/>
-            <a:ext cx="11277295" cy="5230368"/>
+            <a:off x="457200" y="566928"/>
+            <a:ext cx="11277295" cy="411480"/>
+          </a:xfrm>
+          <a:prstGeom prst="rect">
+            <a:avLst/>
+          </a:prstGeom>
+          <a:noFill/>
+        </p:spPr>
+        <p:txBody>
+          <a:bodyPr wrap="square">
+            <a:spAutoFit/>
+          </a:bodyPr>
+          <a:lstStyle/>
+          <a:p>
+            <a:r>
+              <a:rPr sz="1400" b="0" i="0">
+                <a:solidFill>
+                  <a:srgbClr val="B8D8EE"/>
+                </a:solidFill>
+                <a:latin typeface="Calibri"/>
+              </a:rPr>
+              <a:t>«Huellitas» es la clínica (el cliente) · «VetCare DB» es la base de datos que usted construye para ella</a:t>
+            </a:r>
+          </a:p>
+        </p:txBody>
+      </p:sp>
+      <p:sp>
+        <p:nvSpPr>
+          <p:cNvPr id="6" name="TextBox 5"/>
+          <p:cNvSpPr txBox="1"/>
+          <p:nvPr/>
+        </p:nvSpPr>
+        <p:spPr>
+          <a:xfrm>
+            <a:off x="457200" y="1380744"/>
+            <a:ext cx="11277295" cy="5020056"/>
           </a:xfrm>
           <a:prstGeom prst="rect">
             <a:avLst/>
@@ -4084,7 +4119,7 @@
                 </a:solidFill>
                 <a:latin typeface="Calibri"/>
               </a:rPr>
-              <a:t>–   Herramientas </a:t>
+              <a:t>–   Atiende un </a:t>
             </a:r>
             <a:r>
               <a:rPr sz="1600" b="1" i="0">
@@ -4093,7 +4128,7 @@
                 </a:solidFill>
                 <a:latin typeface="Calibri"/>
               </a:rPr>
-              <a:t>gratis en navegador</a:t>
+              <a:t>alto volumen de pacientes</a:t>
             </a:r>
             <a:r>
               <a:rPr sz="1600" b="0" i="0">
@@ -4102,7 +4137,25 @@
                 </a:solidFill>
                 <a:latin typeface="Calibri"/>
               </a:rPr>
-              <a:t> (sin instalacion de SGBD local) — detalle en Plan de curso (pendiente aprobacion docente).</a:t>
+              <a:t> y hoy lleva toda su gestión en </a:t>
+            </a:r>
+            <a:r>
+              <a:rPr sz="1600" b="1" i="0">
+                <a:solidFill>
+                  <a:srgbClr val="333333"/>
+                </a:solidFill>
+                <a:latin typeface="Calibri"/>
+              </a:rPr>
+              <a:t>carpetas de papel</a:t>
+            </a:r>
+            <a:r>
+              <a:rPr sz="1600" b="0" i="0">
+                <a:solidFill>
+                  <a:srgbClr val="333333"/>
+                </a:solidFill>
+                <a:latin typeface="Calibri"/>
+              </a:rPr>
+              <a:t>. La administración reporta tres problemas:</a:t>
             </a:r>
           </a:p>
           <a:p>
@@ -4118,7 +4171,7 @@
                 </a:solidFill>
                 <a:latin typeface="Calibri"/>
               </a:rPr>
-              <a:t>–   </a:t>
+              <a:t>–   Se </a:t>
             </a:r>
             <a:r>
               <a:rPr sz="1600" b="1" i="0">
@@ -4127,7 +4180,7 @@
                 </a:solidFill>
                 <a:latin typeface="Calibri"/>
               </a:rPr>
-              <a:t>ExamLab</a:t>
+              <a:t>extravían fichas</a:t>
             </a:r>
             <a:r>
               <a:rPr sz="1600" b="0" i="0">
@@ -4136,7 +4189,7 @@
                 </a:solidFill>
                 <a:latin typeface="Calibri"/>
               </a:rPr>
-              <a:t> (https://uniaj.examlab.workers.dev/): entrega de talleres + quices/parciales del curso.</a:t>
+              <a:t> de pacientes: el expediente existe en un solo papel.</a:t>
             </a:r>
           </a:p>
           <a:p>
@@ -4152,7 +4205,7 @@
                 </a:solidFill>
                 <a:latin typeface="Calibri"/>
               </a:rPr>
-              <a:t>–   SQL: </a:t>
+              <a:t>–   Buscar un historial en el archivo físico </a:t>
             </a:r>
             <a:r>
               <a:rPr sz="1600" b="1" i="0">
@@ -4161,7 +4214,7 @@
                 </a:solidFill>
                 <a:latin typeface="Calibri"/>
               </a:rPr>
-              <a:t>DB Fiddle</a:t>
+              <a:t>genera filas</a:t>
             </a:r>
             <a:r>
               <a:rPr sz="1600" b="0" i="0">
@@ -4170,25 +4223,7 @@
                 </a:solidFill>
                 <a:latin typeface="Calibri"/>
               </a:rPr>
-              <a:t> / SQLTest.online · PL/SQL: </a:t>
-            </a:r>
-            <a:r>
-              <a:rPr sz="1600" b="1" i="0">
-                <a:solidFill>
-                  <a:srgbClr val="333333"/>
-                </a:solidFill>
-                <a:latin typeface="Calibri"/>
-              </a:rPr>
-              <a:t>Oracle Live SQL</a:t>
-            </a:r>
-            <a:r>
-              <a:rPr sz="1600" b="0" i="0">
-                <a:solidFill>
-                  <a:srgbClr val="333333"/>
-                </a:solidFill>
-                <a:latin typeface="Calibri"/>
-              </a:rPr>
-              <a:t>.</a:t>
+              <a:t> en la sala de espera.</a:t>
             </a:r>
           </a:p>
           <a:p>
@@ -4204,7 +4239,7 @@
                 </a:solidFill>
                 <a:latin typeface="Calibri"/>
               </a:rPr>
-              <a:t>–   Modelos ER: </a:t>
+              <a:t>–   </a:t>
             </a:r>
             <a:r>
               <a:rPr sz="1600" b="1" i="0">
@@ -4213,7 +4248,7 @@
                 </a:solidFill>
                 <a:latin typeface="Calibri"/>
               </a:rPr>
-              <a:t>draw.io / diagrams.net</a:t>
+              <a:t>No hay métricas</a:t>
             </a:r>
             <a:r>
               <a:rPr sz="1600" b="0" i="0">
@@ -4222,25 +4257,7 @@
                 </a:solidFill>
                 <a:latin typeface="Calibri"/>
               </a:rPr>
-              <a:t> · bocetos: </a:t>
-            </a:r>
-            <a:r>
-              <a:rPr sz="1600" b="1" i="0">
-                <a:solidFill>
-                  <a:srgbClr val="333333"/>
-                </a:solidFill>
-                <a:latin typeface="Calibri"/>
-              </a:rPr>
-              <a:t>Excalidraw</a:t>
-            </a:r>
-            <a:r>
-              <a:rPr sz="1600" b="0" i="0">
-                <a:solidFill>
-                  <a:srgbClr val="333333"/>
-                </a:solidFill>
-                <a:latin typeface="Calibri"/>
-              </a:rPr>
-              <a:t>.</a:t>
+              <a:t>: no saben cuántas especies atienden al mes.</a:t>
             </a:r>
           </a:p>
           <a:p>
@@ -4256,14 +4273,50 @@
                 </a:solidFill>
                 <a:latin typeface="Calibri"/>
               </a:rPr>
-              <a:t>–   Bibliografia: Coronel &amp; Morris · Date · Oracle PL/SQL Docs.</a:t>
-            </a:r>
-          </a:p>
-        </p:txBody>
-      </p:sp>
-      <p:sp>
-        <p:nvSpPr>
-          <p:cNvPr id="6" name="TextBox 5"/>
+              <a:t>–   </a:t>
+            </a:r>
+            <a:r>
+              <a:rPr sz="1600" b="1" i="0">
+                <a:solidFill>
+                  <a:srgbClr val="333333"/>
+                </a:solidFill>
+                <a:latin typeface="Calibri"/>
+              </a:rPr>
+              <a:t>Su parte en este curso:</a:t>
+            </a:r>
+            <a:r>
+              <a:rPr sz="1600" b="0" i="0">
+                <a:solidFill>
+                  <a:srgbClr val="333333"/>
+                </a:solidFill>
+                <a:latin typeface="Calibri"/>
+              </a:rPr>
+              <a:t> la </a:t>
+            </a:r>
+            <a:r>
+              <a:rPr sz="1600" b="1" i="0">
+                <a:solidFill>
+                  <a:srgbClr val="333333"/>
+                </a:solidFill>
+                <a:latin typeface="Calibri"/>
+              </a:rPr>
+              <a:t>capa de datos</a:t>
+            </a:r>
+            <a:r>
+              <a:rPr sz="1600" b="0" i="0">
+                <a:solidFill>
+                  <a:srgbClr val="333333"/>
+                </a:solidFill>
+                <a:latin typeface="Calibri"/>
+              </a:rPr>
+              <a:t> de VetCare — modelo, integridad, seguridad y rendimiento. La aplicación y la interfaz no se piden en esta asignatura.</a:t>
+            </a:r>
+          </a:p>
+        </p:txBody>
+      </p:sp>
+      <p:sp>
+        <p:nvSpPr>
+          <p:cNvPr id="7" name="TextBox 6"/>
           <p:cNvSpPr txBox="1"/>
           <p:nvPr/>
         </p:nvSpPr>
@@ -4437,109 +4490,21 @@
                 </a:solidFill>
                 <a:latin typeface="Calibri"/>
               </a:rPr>
-              <a:t>Acuerdos importantes</a:t>
-            </a:r>
-          </a:p>
-        </p:txBody>
-      </p:sp>
-      <p:sp>
-        <p:nvSpPr>
-          <p:cNvPr id="5" name="Rounded Rectangle 4"/>
-          <p:cNvSpPr/>
-          <p:nvPr/>
-        </p:nvSpPr>
-        <p:spPr>
-          <a:xfrm>
-            <a:off x="457200" y="1261872"/>
-            <a:ext cx="11277295" cy="1051560"/>
-          </a:xfrm>
-          <a:prstGeom prst="roundRect">
-            <a:avLst>
-              <a:gd name="adj" fmla="val 12000"/>
-            </a:avLst>
-          </a:prstGeom>
-          <a:solidFill>
-            <a:srgbClr val="E8F4FA"/>
-          </a:solidFill>
-          <a:ln>
-            <a:noFill/>
-          </a:ln>
-        </p:spPr>
-        <p:style>
-          <a:lnRef idx="1">
-            <a:schemeClr val="accent1"/>
-          </a:lnRef>
-          <a:fillRef idx="3">
-            <a:schemeClr val="accent1"/>
-          </a:fillRef>
-          <a:effectRef idx="2">
-            <a:schemeClr val="accent1"/>
-          </a:effectRef>
-          <a:fontRef idx="minor">
-            <a:schemeClr val="lt1"/>
-          </a:fontRef>
-        </p:style>
-        <p:txBody>
-          <a:bodyPr rtlCol="0" anchor="ctr"/>
-          <a:lstStyle/>
-          <a:p>
-            <a:pPr algn="ctr"/>
-          </a:p>
-        </p:txBody>
-      </p:sp>
-      <p:sp>
-        <p:nvSpPr>
-          <p:cNvPr id="6" name="Rectangle 5"/>
-          <p:cNvSpPr/>
-          <p:nvPr/>
-        </p:nvSpPr>
-        <p:spPr>
-          <a:xfrm>
-            <a:off x="457200" y="1261872"/>
-            <a:ext cx="128016" cy="1051560"/>
-          </a:xfrm>
-          <a:prstGeom prst="rect">
-            <a:avLst/>
-          </a:prstGeom>
-          <a:solidFill>
-            <a:srgbClr val="269CCB"/>
-          </a:solidFill>
-          <a:ln>
-            <a:noFill/>
-          </a:ln>
-        </p:spPr>
-        <p:style>
-          <a:lnRef idx="1">
-            <a:schemeClr val="accent1"/>
-          </a:lnRef>
-          <a:fillRef idx="3">
-            <a:schemeClr val="accent1"/>
-          </a:fillRef>
-          <a:effectRef idx="2">
-            <a:schemeClr val="accent1"/>
-          </a:effectRef>
-          <a:fontRef idx="minor">
-            <a:schemeClr val="lt1"/>
-          </a:fontRef>
-        </p:style>
-        <p:txBody>
-          <a:bodyPr rtlCol="0" anchor="ctr"/>
-          <a:lstStyle/>
-          <a:p>
-            <a:pPr algn="ctr"/>
-          </a:p>
-        </p:txBody>
-      </p:sp>
-      <p:sp>
-        <p:nvSpPr>
-          <p:cNvPr id="7" name="TextBox 6"/>
+              <a:t>Recursos</a:t>
+            </a:r>
+          </a:p>
+        </p:txBody>
+      </p:sp>
+      <p:sp>
+        <p:nvSpPr>
+          <p:cNvPr id="5" name="TextBox 4"/>
           <p:cNvSpPr txBox="1"/>
           <p:nvPr/>
         </p:nvSpPr>
         <p:spPr>
           <a:xfrm>
-            <a:off x="777240" y="1399031"/>
-            <a:ext cx="10774375" cy="822959"/>
+            <a:off x="457200" y="1170432"/>
+            <a:ext cx="11277295" cy="5230368"/>
           </a:xfrm>
           <a:prstGeom prst="rect">
             <a:avLst/>
@@ -4552,313 +4517,198 @@
           </a:bodyPr>
           <a:lstStyle/>
           <a:p>
-            <a:r>
-              <a:rPr sz="1200" b="1" i="0">
-                <a:solidFill>
-                  <a:srgbClr val="269CCB"/>
-                </a:solidFill>
-                <a:latin typeface="Calibri"/>
-              </a:rPr>
-              <a:t>Info</a:t>
-            </a:r>
-          </a:p>
-          <a:p>
             <a:pPr>
-              <a:spcBef>
-                <a:spcPts val="400"/>
-              </a:spcBef>
+              <a:spcAft>
+                <a:spcPts val="800"/>
+              </a:spcAft>
             </a:pPr>
             <a:r>
-              <a:rPr sz="1400" b="0" i="0">
-                <a:solidFill>
-                  <a:srgbClr val="333333"/>
-                </a:solidFill>
-                <a:latin typeface="Calibri"/>
-              </a:rPr>
-              <a:t>Lunes 18:00 – 20:00 · Virtual: todas las sesiones por Meet, incluidos la Sesión 1 y los parciales · festivos autónoma · Grupo 641A-2.</a:t>
-            </a:r>
-          </a:p>
-        </p:txBody>
-      </p:sp>
-      <p:sp>
-        <p:nvSpPr>
-          <p:cNvPr id="8" name="Rounded Rectangle 7"/>
-          <p:cNvSpPr/>
-          <p:nvPr/>
-        </p:nvSpPr>
-        <p:spPr>
-          <a:xfrm>
-            <a:off x="457200" y="2478024"/>
-            <a:ext cx="11277295" cy="1051560"/>
-          </a:xfrm>
-          <a:prstGeom prst="roundRect">
-            <a:avLst>
-              <a:gd name="adj" fmla="val 12000"/>
-            </a:avLst>
-          </a:prstGeom>
-          <a:solidFill>
-            <a:srgbClr val="FFF8E1"/>
-          </a:solidFill>
-          <a:ln>
-            <a:noFill/>
-          </a:ln>
-        </p:spPr>
-        <p:style>
-          <a:lnRef idx="1">
-            <a:schemeClr val="accent1"/>
-          </a:lnRef>
-          <a:fillRef idx="3">
-            <a:schemeClr val="accent1"/>
-          </a:fillRef>
-          <a:effectRef idx="2">
-            <a:schemeClr val="accent1"/>
-          </a:effectRef>
-          <a:fontRef idx="minor">
-            <a:schemeClr val="lt1"/>
-          </a:fontRef>
-        </p:style>
-        <p:txBody>
-          <a:bodyPr rtlCol="0" anchor="ctr"/>
-          <a:lstStyle/>
-          <a:p>
-            <a:pPr algn="ctr"/>
-          </a:p>
-        </p:txBody>
-      </p:sp>
-      <p:sp>
-        <p:nvSpPr>
-          <p:cNvPr id="9" name="Rectangle 8"/>
-          <p:cNvSpPr/>
-          <p:nvPr/>
-        </p:nvSpPr>
-        <p:spPr>
-          <a:xfrm>
-            <a:off x="457200" y="2478024"/>
-            <a:ext cx="128016" cy="1051560"/>
-          </a:xfrm>
-          <a:prstGeom prst="rect">
-            <a:avLst/>
-          </a:prstGeom>
-          <a:solidFill>
-            <a:srgbClr val="FFD000"/>
-          </a:solidFill>
-          <a:ln>
-            <a:noFill/>
-          </a:ln>
-        </p:spPr>
-        <p:style>
-          <a:lnRef idx="1">
-            <a:schemeClr val="accent1"/>
-          </a:lnRef>
-          <a:fillRef idx="3">
-            <a:schemeClr val="accent1"/>
-          </a:fillRef>
-          <a:effectRef idx="2">
-            <a:schemeClr val="accent1"/>
-          </a:effectRef>
-          <a:fontRef idx="minor">
-            <a:schemeClr val="lt1"/>
-          </a:fontRef>
-        </p:style>
-        <p:txBody>
-          <a:bodyPr rtlCol="0" anchor="ctr"/>
-          <a:lstStyle/>
-          <a:p>
-            <a:pPr algn="ctr"/>
-          </a:p>
-        </p:txBody>
-      </p:sp>
-      <p:sp>
-        <p:nvSpPr>
-          <p:cNvPr id="10" name="TextBox 9"/>
-          <p:cNvSpPr txBox="1"/>
-          <p:nvPr/>
-        </p:nvSpPr>
-        <p:spPr>
-          <a:xfrm>
-            <a:off x="777240" y="2615184"/>
-            <a:ext cx="10774375" cy="822959"/>
-          </a:xfrm>
-          <a:prstGeom prst="rect">
-            <a:avLst/>
-          </a:prstGeom>
-          <a:noFill/>
-        </p:spPr>
-        <p:txBody>
-          <a:bodyPr wrap="square">
-            <a:spAutoFit/>
-          </a:bodyPr>
-          <a:lstStyle/>
-          <a:p>
-            <a:r>
-              <a:rPr sz="1200" b="1" i="0">
-                <a:solidFill>
-                  <a:srgbClr val="FFD000"/>
-                </a:solidFill>
-                <a:latin typeface="Calibri"/>
-              </a:rPr>
-              <a:t>Aclaración</a:t>
+              <a:rPr sz="1600" b="0" i="0">
+                <a:solidFill>
+                  <a:srgbClr val="333333"/>
+                </a:solidFill>
+                <a:latin typeface="Calibri"/>
+              </a:rPr>
+              <a:t>–   Herramientas </a:t>
+            </a:r>
+            <a:r>
+              <a:rPr sz="1600" b="1" i="0">
+                <a:solidFill>
+                  <a:srgbClr val="333333"/>
+                </a:solidFill>
+                <a:latin typeface="Calibri"/>
+              </a:rPr>
+              <a:t>gratis en navegador</a:t>
+            </a:r>
+            <a:r>
+              <a:rPr sz="1600" b="0" i="0">
+                <a:solidFill>
+                  <a:srgbClr val="333333"/>
+                </a:solidFill>
+                <a:latin typeface="Calibri"/>
+              </a:rPr>
+              <a:t> (sin instalacion de SGBD local) — detalle en Plan de curso (pendiente aprobacion docente).</a:t>
             </a:r>
           </a:p>
           <a:p>
             <a:pPr>
-              <a:spcBef>
-                <a:spcPts val="400"/>
-              </a:spcBef>
+              <a:spcAft>
+                <a:spcPts val="800"/>
+              </a:spcAft>
             </a:pPr>
             <a:r>
-              <a:rPr sz="1400" b="0" i="0">
-                <a:solidFill>
-                  <a:srgbClr val="333333"/>
-                </a:solidFill>
-                <a:latin typeface="Calibri"/>
-              </a:rPr>
-              <a:t>Día 1: Sesión 0 (Presentación del curso, archivo aparte) + Clase 1 (diagnóstico + revisión BD I). Festivos = autónoma con actividad en ExamLab.</a:t>
-            </a:r>
-          </a:p>
-        </p:txBody>
-      </p:sp>
-      <p:sp>
-        <p:nvSpPr>
-          <p:cNvPr id="11" name="Rounded Rectangle 10"/>
-          <p:cNvSpPr/>
-          <p:nvPr/>
-        </p:nvSpPr>
-        <p:spPr>
-          <a:xfrm>
-            <a:off x="457200" y="3694176"/>
-            <a:ext cx="11277295" cy="1051560"/>
-          </a:xfrm>
-          <a:prstGeom prst="roundRect">
-            <a:avLst>
-              <a:gd name="adj" fmla="val 12000"/>
-            </a:avLst>
-          </a:prstGeom>
-          <a:solidFill>
-            <a:srgbClr val="FBE4E4"/>
-          </a:solidFill>
-          <a:ln>
-            <a:noFill/>
-          </a:ln>
-        </p:spPr>
-        <p:style>
-          <a:lnRef idx="1">
-            <a:schemeClr val="accent1"/>
-          </a:lnRef>
-          <a:fillRef idx="3">
-            <a:schemeClr val="accent1"/>
-          </a:fillRef>
-          <a:effectRef idx="2">
-            <a:schemeClr val="accent1"/>
-          </a:effectRef>
-          <a:fontRef idx="minor">
-            <a:schemeClr val="lt1"/>
-          </a:fontRef>
-        </p:style>
-        <p:txBody>
-          <a:bodyPr rtlCol="0" anchor="ctr"/>
-          <a:lstStyle/>
-          <a:p>
-            <a:pPr algn="ctr"/>
-          </a:p>
-        </p:txBody>
-      </p:sp>
-      <p:sp>
-        <p:nvSpPr>
-          <p:cNvPr id="12" name="Rectangle 11"/>
-          <p:cNvSpPr/>
-          <p:nvPr/>
-        </p:nvSpPr>
-        <p:spPr>
-          <a:xfrm>
-            <a:off x="457200" y="3694176"/>
-            <a:ext cx="128016" cy="1051560"/>
-          </a:xfrm>
-          <a:prstGeom prst="rect">
-            <a:avLst/>
-          </a:prstGeom>
-          <a:solidFill>
-            <a:srgbClr val="A02030"/>
-          </a:solidFill>
-          <a:ln>
-            <a:noFill/>
-          </a:ln>
-        </p:spPr>
-        <p:style>
-          <a:lnRef idx="1">
-            <a:schemeClr val="accent1"/>
-          </a:lnRef>
-          <a:fillRef idx="3">
-            <a:schemeClr val="accent1"/>
-          </a:fillRef>
-          <a:effectRef idx="2">
-            <a:schemeClr val="accent1"/>
-          </a:effectRef>
-          <a:fontRef idx="minor">
-            <a:schemeClr val="lt1"/>
-          </a:fontRef>
-        </p:style>
-        <p:txBody>
-          <a:bodyPr rtlCol="0" anchor="ctr"/>
-          <a:lstStyle/>
-          <a:p>
-            <a:pPr algn="ctr"/>
-          </a:p>
-        </p:txBody>
-      </p:sp>
-      <p:sp>
-        <p:nvSpPr>
-          <p:cNvPr id="13" name="TextBox 12"/>
-          <p:cNvSpPr txBox="1"/>
-          <p:nvPr/>
-        </p:nvSpPr>
-        <p:spPr>
-          <a:xfrm>
-            <a:off x="777240" y="3831336"/>
-            <a:ext cx="10774375" cy="822959"/>
-          </a:xfrm>
-          <a:prstGeom prst="rect">
-            <a:avLst/>
-          </a:prstGeom>
-          <a:noFill/>
-        </p:spPr>
-        <p:txBody>
-          <a:bodyPr wrap="square">
-            <a:spAutoFit/>
-          </a:bodyPr>
-          <a:lstStyle/>
-          <a:p>
-            <a:r>
-              <a:rPr sz="1200" b="1" i="0">
-                <a:solidFill>
-                  <a:srgbClr val="A02030"/>
-                </a:solidFill>
-                <a:latin typeface="Calibri"/>
-              </a:rPr>
-              <a:t>Atención</a:t>
+              <a:rPr sz="1600" b="0" i="0">
+                <a:solidFill>
+                  <a:srgbClr val="333333"/>
+                </a:solidFill>
+                <a:latin typeface="Calibri"/>
+              </a:rPr>
+              <a:t>–   </a:t>
+            </a:r>
+            <a:r>
+              <a:rPr sz="1600" b="1" i="0">
+                <a:solidFill>
+                  <a:srgbClr val="333333"/>
+                </a:solidFill>
+                <a:latin typeface="Calibri"/>
+              </a:rPr>
+              <a:t>ExamLab</a:t>
+            </a:r>
+            <a:r>
+              <a:rPr sz="1600" b="0" i="0">
+                <a:solidFill>
+                  <a:srgbClr val="333333"/>
+                </a:solidFill>
+                <a:latin typeface="Calibri"/>
+              </a:rPr>
+              <a:t> (https://uniaj.examlab.workers.dev/): entrega de talleres + quices/parciales del curso.</a:t>
             </a:r>
           </a:p>
           <a:p>
             <a:pPr>
-              <a:spcBef>
-                <a:spcPts val="400"/>
-              </a:spcBef>
+              <a:spcAft>
+                <a:spcPts val="800"/>
+              </a:spcAft>
             </a:pPr>
             <a:r>
-              <a:rPr sz="1400" b="0" i="0">
-                <a:solidFill>
-                  <a:srgbClr val="333333"/>
-                </a:solidFill>
-                <a:latin typeface="Calibri"/>
-              </a:rPr>
-              <a:t>Parciales NUNCA en autonoma: P1=sesión 5 (21/09), P2=sesión 9 (19/10), P3=sesión 12 (09/11). La sesión 13 (16/11) es de sustentación del PI VetCare.</a:t>
-            </a:r>
-          </a:p>
-        </p:txBody>
-      </p:sp>
-      <p:sp>
-        <p:nvSpPr>
-          <p:cNvPr id="14" name="TextBox 13"/>
+              <a:rPr sz="1600" b="0" i="0">
+                <a:solidFill>
+                  <a:srgbClr val="333333"/>
+                </a:solidFill>
+                <a:latin typeface="Calibri"/>
+              </a:rPr>
+              <a:t>–   SQL: </a:t>
+            </a:r>
+            <a:r>
+              <a:rPr sz="1600" b="1" i="0">
+                <a:solidFill>
+                  <a:srgbClr val="333333"/>
+                </a:solidFill>
+                <a:latin typeface="Calibri"/>
+              </a:rPr>
+              <a:t>DB Fiddle</a:t>
+            </a:r>
+            <a:r>
+              <a:rPr sz="1600" b="0" i="0">
+                <a:solidFill>
+                  <a:srgbClr val="333333"/>
+                </a:solidFill>
+                <a:latin typeface="Calibri"/>
+              </a:rPr>
+              <a:t> / SQLTest.online · PL/SQL: </a:t>
+            </a:r>
+            <a:r>
+              <a:rPr sz="1600" b="1" i="0">
+                <a:solidFill>
+                  <a:srgbClr val="333333"/>
+                </a:solidFill>
+                <a:latin typeface="Calibri"/>
+              </a:rPr>
+              <a:t>Oracle Live SQL</a:t>
+            </a:r>
+            <a:r>
+              <a:rPr sz="1600" b="0" i="0">
+                <a:solidFill>
+                  <a:srgbClr val="333333"/>
+                </a:solidFill>
+                <a:latin typeface="Calibri"/>
+              </a:rPr>
+              <a:t>.</a:t>
+            </a:r>
+          </a:p>
+          <a:p>
+            <a:pPr>
+              <a:spcAft>
+                <a:spcPts val="800"/>
+              </a:spcAft>
+            </a:pPr>
+            <a:r>
+              <a:rPr sz="1600" b="0" i="0">
+                <a:solidFill>
+                  <a:srgbClr val="333333"/>
+                </a:solidFill>
+                <a:latin typeface="Calibri"/>
+              </a:rPr>
+              <a:t>–   Modelos ER: </a:t>
+            </a:r>
+            <a:r>
+              <a:rPr sz="1600" b="1" i="0">
+                <a:solidFill>
+                  <a:srgbClr val="333333"/>
+                </a:solidFill>
+                <a:latin typeface="Calibri"/>
+              </a:rPr>
+              <a:t>draw.io / diagrams.net</a:t>
+            </a:r>
+            <a:r>
+              <a:rPr sz="1600" b="0" i="0">
+                <a:solidFill>
+                  <a:srgbClr val="333333"/>
+                </a:solidFill>
+                <a:latin typeface="Calibri"/>
+              </a:rPr>
+              <a:t> · bocetos: </a:t>
+            </a:r>
+            <a:r>
+              <a:rPr sz="1600" b="1" i="0">
+                <a:solidFill>
+                  <a:srgbClr val="333333"/>
+                </a:solidFill>
+                <a:latin typeface="Calibri"/>
+              </a:rPr>
+              <a:t>Excalidraw</a:t>
+            </a:r>
+            <a:r>
+              <a:rPr sz="1600" b="0" i="0">
+                <a:solidFill>
+                  <a:srgbClr val="333333"/>
+                </a:solidFill>
+                <a:latin typeface="Calibri"/>
+              </a:rPr>
+              <a:t>.</a:t>
+            </a:r>
+          </a:p>
+          <a:p>
+            <a:pPr>
+              <a:spcAft>
+                <a:spcPts val="800"/>
+              </a:spcAft>
+            </a:pPr>
+            <a:r>
+              <a:rPr sz="1600" b="0" i="0">
+                <a:solidFill>
+                  <a:srgbClr val="333333"/>
+                </a:solidFill>
+                <a:latin typeface="Calibri"/>
+              </a:rPr>
+              <a:t>–   Bibliografia: Coronel &amp; Morris · Date · Oracle PL/SQL Docs.</a:t>
+            </a:r>
+          </a:p>
+        </p:txBody>
+      </p:sp>
+      <p:sp>
+        <p:nvSpPr>
+          <p:cNvPr id="6" name="TextBox 5"/>
           <p:cNvSpPr txBox="1"/>
           <p:nvPr/>
         </p:nvSpPr>
@@ -4926,7 +4776,7 @@
         <p:spPr>
           <a:xfrm>
             <a:off x="0" y="0"/>
-            <a:ext cx="12191695" cy="1170432"/>
+            <a:ext cx="12191695" cy="960120"/>
           </a:xfrm>
           <a:prstGeom prst="rect">
             <a:avLst/>
@@ -4968,7 +4818,7 @@
         </p:nvSpPr>
         <p:spPr>
           <a:xfrm>
-            <a:off x="0" y="1170432"/>
+            <a:off x="0" y="960120"/>
             <a:ext cx="12191695" cy="41148"/>
           </a:xfrm>
           <a:prstGeom prst="rect">
@@ -5012,7 +4862,7 @@
         <p:spPr>
           <a:xfrm>
             <a:off x="457200" y="164592"/>
-            <a:ext cx="11277295" cy="384048"/>
+            <a:ext cx="11277295" cy="502920"/>
           </a:xfrm>
           <a:prstGeom prst="rect">
             <a:avLst/>
@@ -5032,55 +4882,21 @@
                 </a:solidFill>
                 <a:latin typeface="Calibri"/>
               </a:rPr>
-              <a:t>Herramientas del curso</a:t>
-            </a:r>
-          </a:p>
-        </p:txBody>
-      </p:sp>
-      <p:sp>
-        <p:nvSpPr>
-          <p:cNvPr id="5" name="TextBox 4"/>
-          <p:cNvSpPr txBox="1"/>
-          <p:nvPr/>
-        </p:nvSpPr>
-        <p:spPr>
-          <a:xfrm>
-            <a:off x="457200" y="566928"/>
-            <a:ext cx="11277295" cy="411480"/>
-          </a:xfrm>
-          <a:prstGeom prst="rect">
-            <a:avLst/>
-          </a:prstGeom>
-          <a:noFill/>
-        </p:spPr>
-        <p:txBody>
-          <a:bodyPr wrap="square">
-            <a:spAutoFit/>
-          </a:bodyPr>
-          <a:lstStyle/>
-          <a:p>
-            <a:r>
-              <a:rPr sz="1400" b="0" i="0">
-                <a:solidFill>
-                  <a:srgbClr val="B8D8EE"/>
-                </a:solidFill>
-                <a:latin typeface="Calibri"/>
-              </a:rPr>
-              <a:t>Gratis en navegador · SQL + diagramas ER + entrega/evaluación</a:t>
-            </a:r>
-          </a:p>
-        </p:txBody>
-      </p:sp>
-      <p:sp>
-        <p:nvSpPr>
-          <p:cNvPr id="6" name="Rounded Rectangle 5"/>
+              <a:t>Acuerdos importantes</a:t>
+            </a:r>
+          </a:p>
+        </p:txBody>
+      </p:sp>
+      <p:sp>
+        <p:nvSpPr>
+          <p:cNvPr id="5" name="Rounded Rectangle 4"/>
           <p:cNvSpPr/>
           <p:nvPr/>
         </p:nvSpPr>
         <p:spPr>
           <a:xfrm>
-            <a:off x="457200" y="1591056"/>
-            <a:ext cx="3624986" cy="2299716"/>
+            <a:off x="457200" y="1261872"/>
+            <a:ext cx="11277295" cy="1051560"/>
           </a:xfrm>
           <a:prstGeom prst="roundRect">
             <a:avLst>
@@ -5088,7 +4904,7 @@
             </a:avLst>
           </a:prstGeom>
           <a:solidFill>
-            <a:srgbClr val="F2F2F2"/>
+            <a:srgbClr val="E8F4FA"/>
           </a:solidFill>
           <a:ln>
             <a:noFill/>
@@ -5118,20 +4934,20 @@
       </p:sp>
       <p:sp>
         <p:nvSpPr>
-          <p:cNvPr id="7" name="Rectangle 6"/>
+          <p:cNvPr id="6" name="Rectangle 5"/>
           <p:cNvSpPr/>
           <p:nvPr/>
         </p:nvSpPr>
         <p:spPr>
           <a:xfrm>
-            <a:off x="457200" y="1591056"/>
-            <a:ext cx="3624986" cy="64008"/>
+            <a:off x="457200" y="1261872"/>
+            <a:ext cx="128016" cy="1051560"/>
           </a:xfrm>
           <a:prstGeom prst="rect">
             <a:avLst/>
           </a:prstGeom>
           <a:solidFill>
-            <a:srgbClr val="095292"/>
+            <a:srgbClr val="269CCB"/>
           </a:solidFill>
           <a:ln>
             <a:noFill/>
@@ -5161,14 +4977,109 @@
       </p:sp>
       <p:sp>
         <p:nvSpPr>
-          <p:cNvPr id="8" name="Rectangle 7"/>
+          <p:cNvPr id="7" name="TextBox 6"/>
+          <p:cNvSpPr txBox="1"/>
+          <p:nvPr/>
+        </p:nvSpPr>
+        <p:spPr>
+          <a:xfrm>
+            <a:off x="777240" y="1399031"/>
+            <a:ext cx="10774375" cy="822959"/>
+          </a:xfrm>
+          <a:prstGeom prst="rect">
+            <a:avLst/>
+          </a:prstGeom>
+          <a:noFill/>
+        </p:spPr>
+        <p:txBody>
+          <a:bodyPr wrap="square">
+            <a:spAutoFit/>
+          </a:bodyPr>
+          <a:lstStyle/>
+          <a:p>
+            <a:r>
+              <a:rPr sz="1200" b="1" i="0">
+                <a:solidFill>
+                  <a:srgbClr val="269CCB"/>
+                </a:solidFill>
+                <a:latin typeface="Calibri"/>
+              </a:rPr>
+              <a:t>Info</a:t>
+            </a:r>
+          </a:p>
+          <a:p>
+            <a:pPr>
+              <a:spcBef>
+                <a:spcPts val="400"/>
+              </a:spcBef>
+            </a:pPr>
+            <a:r>
+              <a:rPr sz="1400" b="0" i="0">
+                <a:solidFill>
+                  <a:srgbClr val="333333"/>
+                </a:solidFill>
+                <a:latin typeface="Calibri"/>
+              </a:rPr>
+              <a:t>Lunes 18:00 – 20:00 · Virtual: todas las sesiones por Meet, incluidos la Sesión 1 y los parciales · festivos autónoma · Grupo 641A-2.</a:t>
+            </a:r>
+          </a:p>
+        </p:txBody>
+      </p:sp>
+      <p:sp>
+        <p:nvSpPr>
+          <p:cNvPr id="8" name="Rounded Rectangle 7"/>
           <p:cNvSpPr/>
           <p:nvPr/>
         </p:nvSpPr>
         <p:spPr>
           <a:xfrm>
-            <a:off x="457200" y="1655064"/>
-            <a:ext cx="3624986" cy="27432"/>
+            <a:off x="457200" y="2478024"/>
+            <a:ext cx="11277295" cy="1051560"/>
+          </a:xfrm>
+          <a:prstGeom prst="roundRect">
+            <a:avLst>
+              <a:gd name="adj" fmla="val 12000"/>
+            </a:avLst>
+          </a:prstGeom>
+          <a:solidFill>
+            <a:srgbClr val="FFF8E1"/>
+          </a:solidFill>
+          <a:ln>
+            <a:noFill/>
+          </a:ln>
+        </p:spPr>
+        <p:style>
+          <a:lnRef idx="1">
+            <a:schemeClr val="accent1"/>
+          </a:lnRef>
+          <a:fillRef idx="3">
+            <a:schemeClr val="accent1"/>
+          </a:fillRef>
+          <a:effectRef idx="2">
+            <a:schemeClr val="accent1"/>
+          </a:effectRef>
+          <a:fontRef idx="minor">
+            <a:schemeClr val="lt1"/>
+          </a:fontRef>
+        </p:style>
+        <p:txBody>
+          <a:bodyPr rtlCol="0" anchor="ctr"/>
+          <a:lstStyle/>
+          <a:p>
+            <a:pPr algn="ctr"/>
+          </a:p>
+        </p:txBody>
+      </p:sp>
+      <p:sp>
+        <p:nvSpPr>
+          <p:cNvPr id="9" name="Rectangle 8"/>
+          <p:cNvSpPr/>
+          <p:nvPr/>
+        </p:nvSpPr>
+        <p:spPr>
+          <a:xfrm>
+            <a:off x="457200" y="2478024"/>
+            <a:ext cx="128016" cy="1051560"/>
           </a:xfrm>
           <a:prstGeom prst="rect">
             <a:avLst/>
@@ -5202,30 +5113,6 @@
           </a:p>
         </p:txBody>
       </p:sp>
-      <p:pic>
-        <p:nvPicPr>
-          <p:cNvPr id="9" name="Picture 8" descr="dbfiddle.png"/>
-          <p:cNvPicPr>
-            <a:picLocks noChangeAspect="1"/>
-          </p:cNvPicPr>
-          <p:nvPr/>
-        </p:nvPicPr>
-        <p:blipFill>
-          <a:blip r:embed="rId2"/>
-          <a:stretch>
-            <a:fillRect/>
-          </a:stretch>
-        </p:blipFill>
-        <p:spPr>
-          <a:xfrm>
-            <a:off x="1659331" y="1847087"/>
-            <a:ext cx="1220724" cy="1220724"/>
-          </a:xfrm>
-          <a:prstGeom prst="rect">
-            <a:avLst/>
-          </a:prstGeom>
-        </p:spPr>
-      </p:pic>
       <p:sp>
         <p:nvSpPr>
           <p:cNvPr id="10" name="TextBox 9"/>
@@ -5234,8 +5121,8 @@
         </p:nvSpPr>
         <p:spPr>
           <a:xfrm>
-            <a:off x="530352" y="3159251"/>
-            <a:ext cx="3478682" cy="621792"/>
+            <a:off x="777240" y="2615184"/>
+            <a:ext cx="10774375" cy="822959"/>
           </a:xfrm>
           <a:prstGeom prst="rect">
             <a:avLst/>
@@ -5243,34 +5130,35 @@
           <a:noFill/>
         </p:spPr>
         <p:txBody>
-          <a:bodyPr wrap="square" anchor="t"/>
-          <a:lstStyle/>
-          <a:p>
-            <a:pPr algn="ctr"/>
-            <a:r>
-              <a:rPr sz="1300" b="1" i="0">
-                <a:solidFill>
-                  <a:srgbClr val="095292"/>
-                </a:solidFill>
-                <a:latin typeface="Calibri"/>
-              </a:rPr>
-              <a:t>DB Fiddle</a:t>
-            </a:r>
-          </a:p>
-          <a:p>
-            <a:pPr algn="ctr">
+          <a:bodyPr wrap="square">
+            <a:spAutoFit/>
+          </a:bodyPr>
+          <a:lstStyle/>
+          <a:p>
+            <a:r>
+              <a:rPr sz="1200" b="1" i="0">
+                <a:solidFill>
+                  <a:srgbClr val="FFD000"/>
+                </a:solidFill>
+                <a:latin typeface="Calibri"/>
+              </a:rPr>
+              <a:t>Aclaración</a:t>
+            </a:r>
+          </a:p>
+          <a:p>
+            <a:pPr>
               <a:spcBef>
-                <a:spcPts val="200"/>
+                <a:spcPts val="400"/>
               </a:spcBef>
             </a:pPr>
             <a:r>
-              <a:rPr sz="1000" b="0" i="0">
-                <a:solidFill>
-                  <a:srgbClr val="666666"/>
-                </a:solidFill>
-                <a:latin typeface="Calibri"/>
-              </a:rPr>
-              <a:t>SQL práctico</a:t>
+              <a:rPr sz="1400" b="0" i="0">
+                <a:solidFill>
+                  <a:srgbClr val="333333"/>
+                </a:solidFill>
+                <a:latin typeface="Calibri"/>
+              </a:rPr>
+              <a:t>Día 1: Sesión 0 (Presentación del curso, archivo aparte) + Clase 1 (diagnóstico + revisión BD I). Festivos = autónoma con actividad en ExamLab.</a:t>
             </a:r>
           </a:p>
         </p:txBody>
@@ -5283,8 +5171,8 @@
         </p:nvSpPr>
         <p:spPr>
           <a:xfrm>
-            <a:off x="4283354" y="1591056"/>
-            <a:ext cx="3624986" cy="2299716"/>
+            <a:off x="457200" y="3694176"/>
+            <a:ext cx="11277295" cy="1051560"/>
           </a:xfrm>
           <a:prstGeom prst="roundRect">
             <a:avLst>
@@ -5292,7 +5180,7 @@
             </a:avLst>
           </a:prstGeom>
           <a:solidFill>
-            <a:srgbClr val="F2F2F2"/>
+            <a:srgbClr val="FBE4E4"/>
           </a:solidFill>
           <a:ln>
             <a:noFill/>
@@ -5328,14 +5216,14 @@
         </p:nvSpPr>
         <p:spPr>
           <a:xfrm>
-            <a:off x="4283354" y="1591056"/>
-            <a:ext cx="3624986" cy="64008"/>
+            <a:off x="457200" y="3694176"/>
+            <a:ext cx="128016" cy="1051560"/>
           </a:xfrm>
           <a:prstGeom prst="rect">
             <a:avLst/>
           </a:prstGeom>
           <a:solidFill>
-            <a:srgbClr val="095292"/>
+            <a:srgbClr val="A02030"/>
           </a:solidFill>
           <a:ln>
             <a:noFill/>
@@ -5365,81 +5253,14 @@
       </p:sp>
       <p:sp>
         <p:nvSpPr>
-          <p:cNvPr id="13" name="Rectangle 12"/>
-          <p:cNvSpPr/>
-          <p:nvPr/>
-        </p:nvSpPr>
-        <p:spPr>
-          <a:xfrm>
-            <a:off x="4283354" y="1655064"/>
-            <a:ext cx="3624986" cy="27432"/>
-          </a:xfrm>
-          <a:prstGeom prst="rect">
-            <a:avLst/>
-          </a:prstGeom>
-          <a:solidFill>
-            <a:srgbClr val="FFD000"/>
-          </a:solidFill>
-          <a:ln>
-            <a:noFill/>
-          </a:ln>
-        </p:spPr>
-        <p:style>
-          <a:lnRef idx="1">
-            <a:schemeClr val="accent1"/>
-          </a:lnRef>
-          <a:fillRef idx="3">
-            <a:schemeClr val="accent1"/>
-          </a:fillRef>
-          <a:effectRef idx="2">
-            <a:schemeClr val="accent1"/>
-          </a:effectRef>
-          <a:fontRef idx="minor">
-            <a:schemeClr val="lt1"/>
-          </a:fontRef>
-        </p:style>
-        <p:txBody>
-          <a:bodyPr rtlCol="0" anchor="ctr"/>
-          <a:lstStyle/>
-          <a:p>
-            <a:pPr algn="ctr"/>
-          </a:p>
-        </p:txBody>
-      </p:sp>
-      <p:pic>
-        <p:nvPicPr>
-          <p:cNvPr id="14" name="Picture 13" descr="oracle_livesql.png"/>
-          <p:cNvPicPr>
-            <a:picLocks noChangeAspect="1"/>
-          </p:cNvPicPr>
-          <p:nvPr/>
-        </p:nvPicPr>
-        <p:blipFill>
-          <a:blip r:embed="rId3"/>
-          <a:stretch>
-            <a:fillRect/>
-          </a:stretch>
-        </p:blipFill>
-        <p:spPr>
-          <a:xfrm>
-            <a:off x="5485485" y="1847087"/>
-            <a:ext cx="1220724" cy="1220724"/>
-          </a:xfrm>
-          <a:prstGeom prst="rect">
-            <a:avLst/>
-          </a:prstGeom>
-        </p:spPr>
-      </p:pic>
-      <p:sp>
-        <p:nvSpPr>
-          <p:cNvPr id="15" name="TextBox 14"/>
+          <p:cNvPr id="13" name="TextBox 12"/>
           <p:cNvSpPr txBox="1"/>
           <p:nvPr/>
         </p:nvSpPr>
         <p:spPr>
           <a:xfrm>
-            <a:off x="4356506" y="3159251"/>
-            <a:ext cx="3478682" cy="621792"/>
+            <a:off x="777240" y="3831336"/>
+            <a:ext cx="10774375" cy="822959"/>
           </a:xfrm>
           <a:prstGeom prst="rect">
             <a:avLst/>
@@ -5447,653 +5268,42 @@
           <a:noFill/>
         </p:spPr>
         <p:txBody>
-          <a:bodyPr wrap="square" anchor="t"/>
-          <a:lstStyle/>
-          <a:p>
-            <a:pPr algn="ctr"/>
-            <a:r>
-              <a:rPr sz="1300" b="1" i="0">
-                <a:solidFill>
-                  <a:srgbClr val="095292"/>
-                </a:solidFill>
-                <a:latin typeface="Calibri"/>
-              </a:rPr>
-              <a:t>Oracle Live SQL</a:t>
-            </a:r>
-          </a:p>
-          <a:p>
-            <a:pPr algn="ctr">
+          <a:bodyPr wrap="square">
+            <a:spAutoFit/>
+          </a:bodyPr>
+          <a:lstStyle/>
+          <a:p>
+            <a:r>
+              <a:rPr sz="1200" b="1" i="0">
+                <a:solidFill>
+                  <a:srgbClr val="A02030"/>
+                </a:solidFill>
+                <a:latin typeface="Calibri"/>
+              </a:rPr>
+              <a:t>Atención</a:t>
+            </a:r>
+          </a:p>
+          <a:p>
+            <a:pPr>
               <a:spcBef>
-                <a:spcPts val="200"/>
+                <a:spcPts val="400"/>
               </a:spcBef>
             </a:pPr>
             <a:r>
-              <a:rPr sz="1000" b="0" i="0">
-                <a:solidFill>
-                  <a:srgbClr val="666666"/>
-                </a:solidFill>
-                <a:latin typeface="Calibri"/>
-              </a:rPr>
-              <a:t>PL/SQL · cuenta free</a:t>
-            </a:r>
-          </a:p>
-        </p:txBody>
-      </p:sp>
-      <p:sp>
-        <p:nvSpPr>
-          <p:cNvPr id="16" name="Rounded Rectangle 15"/>
-          <p:cNvSpPr/>
-          <p:nvPr/>
-        </p:nvSpPr>
-        <p:spPr>
-          <a:xfrm>
-            <a:off x="8109508" y="1591056"/>
-            <a:ext cx="3624986" cy="2299716"/>
-          </a:xfrm>
-          <a:prstGeom prst="roundRect">
-            <a:avLst>
-              <a:gd name="adj" fmla="val 12000"/>
-            </a:avLst>
-          </a:prstGeom>
-          <a:solidFill>
-            <a:srgbClr val="F2F2F2"/>
-          </a:solidFill>
-          <a:ln>
-            <a:noFill/>
-          </a:ln>
-        </p:spPr>
-        <p:style>
-          <a:lnRef idx="1">
-            <a:schemeClr val="accent1"/>
-          </a:lnRef>
-          <a:fillRef idx="3">
-            <a:schemeClr val="accent1"/>
-          </a:fillRef>
-          <a:effectRef idx="2">
-            <a:schemeClr val="accent1"/>
-          </a:effectRef>
-          <a:fontRef idx="minor">
-            <a:schemeClr val="lt1"/>
-          </a:fontRef>
-        </p:style>
-        <p:txBody>
-          <a:bodyPr rtlCol="0" anchor="ctr"/>
-          <a:lstStyle/>
-          <a:p>
-            <a:pPr algn="ctr"/>
-          </a:p>
-        </p:txBody>
-      </p:sp>
-      <p:sp>
-        <p:nvSpPr>
-          <p:cNvPr id="17" name="Rectangle 16"/>
-          <p:cNvSpPr/>
-          <p:nvPr/>
-        </p:nvSpPr>
-        <p:spPr>
-          <a:xfrm>
-            <a:off x="8109508" y="1591056"/>
-            <a:ext cx="3624986" cy="64008"/>
-          </a:xfrm>
-          <a:prstGeom prst="rect">
-            <a:avLst/>
-          </a:prstGeom>
-          <a:solidFill>
-            <a:srgbClr val="095292"/>
-          </a:solidFill>
-          <a:ln>
-            <a:noFill/>
-          </a:ln>
-        </p:spPr>
-        <p:style>
-          <a:lnRef idx="1">
-            <a:schemeClr val="accent1"/>
-          </a:lnRef>
-          <a:fillRef idx="3">
-            <a:schemeClr val="accent1"/>
-          </a:fillRef>
-          <a:effectRef idx="2">
-            <a:schemeClr val="accent1"/>
-          </a:effectRef>
-          <a:fontRef idx="minor">
-            <a:schemeClr val="lt1"/>
-          </a:fontRef>
-        </p:style>
-        <p:txBody>
-          <a:bodyPr rtlCol="0" anchor="ctr"/>
-          <a:lstStyle/>
-          <a:p>
-            <a:pPr algn="ctr"/>
-          </a:p>
-        </p:txBody>
-      </p:sp>
-      <p:sp>
-        <p:nvSpPr>
-          <p:cNvPr id="18" name="Rectangle 17"/>
-          <p:cNvSpPr/>
-          <p:nvPr/>
-        </p:nvSpPr>
-        <p:spPr>
-          <a:xfrm>
-            <a:off x="8109508" y="1655064"/>
-            <a:ext cx="3624986" cy="27432"/>
-          </a:xfrm>
-          <a:prstGeom prst="rect">
-            <a:avLst/>
-          </a:prstGeom>
-          <a:solidFill>
-            <a:srgbClr val="FFD000"/>
-          </a:solidFill>
-          <a:ln>
-            <a:noFill/>
-          </a:ln>
-        </p:spPr>
-        <p:style>
-          <a:lnRef idx="1">
-            <a:schemeClr val="accent1"/>
-          </a:lnRef>
-          <a:fillRef idx="3">
-            <a:schemeClr val="accent1"/>
-          </a:fillRef>
-          <a:effectRef idx="2">
-            <a:schemeClr val="accent1"/>
-          </a:effectRef>
-          <a:fontRef idx="minor">
-            <a:schemeClr val="lt1"/>
-          </a:fontRef>
-        </p:style>
-        <p:txBody>
-          <a:bodyPr rtlCol="0" anchor="ctr"/>
-          <a:lstStyle/>
-          <a:p>
-            <a:pPr algn="ctr"/>
-          </a:p>
-        </p:txBody>
-      </p:sp>
-      <p:pic>
-        <p:nvPicPr>
-          <p:cNvPr id="19" name="Picture 18" descr="drawio.png"/>
-          <p:cNvPicPr>
-            <a:picLocks noChangeAspect="1"/>
-          </p:cNvPicPr>
-          <p:nvPr/>
-        </p:nvPicPr>
-        <p:blipFill>
-          <a:blip r:embed="rId4"/>
-          <a:stretch>
-            <a:fillRect/>
-          </a:stretch>
-        </p:blipFill>
-        <p:spPr>
-          <a:xfrm>
-            <a:off x="9311640" y="1847087"/>
-            <a:ext cx="1220724" cy="1220724"/>
-          </a:xfrm>
-          <a:prstGeom prst="rect">
-            <a:avLst/>
-          </a:prstGeom>
-        </p:spPr>
-      </p:pic>
-      <p:sp>
-        <p:nvSpPr>
-          <p:cNvPr id="20" name="TextBox 19"/>
-          <p:cNvSpPr txBox="1"/>
-          <p:nvPr/>
-        </p:nvSpPr>
-        <p:spPr>
-          <a:xfrm>
-            <a:off x="8182660" y="3159251"/>
-            <a:ext cx="3478682" cy="621792"/>
-          </a:xfrm>
-          <a:prstGeom prst="rect">
-            <a:avLst/>
-          </a:prstGeom>
-          <a:noFill/>
-        </p:spPr>
-        <p:txBody>
-          <a:bodyPr wrap="square" anchor="t"/>
-          <a:lstStyle/>
-          <a:p>
-            <a:pPr algn="ctr"/>
-            <a:r>
-              <a:rPr sz="1300" b="1" i="0">
-                <a:solidFill>
-                  <a:srgbClr val="095292"/>
-                </a:solidFill>
-                <a:latin typeface="Calibri"/>
-              </a:rPr>
-              <a:t>draw.io</a:t>
-            </a:r>
-          </a:p>
-          <a:p>
-            <a:pPr algn="ctr">
-              <a:spcBef>
-                <a:spcPts val="200"/>
-              </a:spcBef>
-            </a:pPr>
-            <a:r>
-              <a:rPr sz="1000" b="0" i="0">
-                <a:solidFill>
-                  <a:srgbClr val="666666"/>
-                </a:solidFill>
-                <a:latin typeface="Calibri"/>
-              </a:rPr>
-              <a:t>Modelos ER</a:t>
-            </a:r>
-          </a:p>
-        </p:txBody>
-      </p:sp>
-      <p:sp>
-        <p:nvSpPr>
-          <p:cNvPr id="21" name="Rounded Rectangle 20"/>
-          <p:cNvSpPr/>
-          <p:nvPr/>
-        </p:nvSpPr>
-        <p:spPr>
-          <a:xfrm>
-            <a:off x="2370277" y="4055364"/>
-            <a:ext cx="3624986" cy="2299716"/>
-          </a:xfrm>
-          <a:prstGeom prst="roundRect">
-            <a:avLst>
-              <a:gd name="adj" fmla="val 12000"/>
-            </a:avLst>
-          </a:prstGeom>
-          <a:solidFill>
-            <a:srgbClr val="F2F2F2"/>
-          </a:solidFill>
-          <a:ln>
-            <a:noFill/>
-          </a:ln>
-        </p:spPr>
-        <p:style>
-          <a:lnRef idx="1">
-            <a:schemeClr val="accent1"/>
-          </a:lnRef>
-          <a:fillRef idx="3">
-            <a:schemeClr val="accent1"/>
-          </a:fillRef>
-          <a:effectRef idx="2">
-            <a:schemeClr val="accent1"/>
-          </a:effectRef>
-          <a:fontRef idx="minor">
-            <a:schemeClr val="lt1"/>
-          </a:fontRef>
-        </p:style>
-        <p:txBody>
-          <a:bodyPr rtlCol="0" anchor="ctr"/>
-          <a:lstStyle/>
-          <a:p>
-            <a:pPr algn="ctr"/>
-          </a:p>
-        </p:txBody>
-      </p:sp>
-      <p:sp>
-        <p:nvSpPr>
-          <p:cNvPr id="22" name="Rectangle 21"/>
-          <p:cNvSpPr/>
-          <p:nvPr/>
-        </p:nvSpPr>
-        <p:spPr>
-          <a:xfrm>
-            <a:off x="2370277" y="4055364"/>
-            <a:ext cx="3624986" cy="64008"/>
-          </a:xfrm>
-          <a:prstGeom prst="rect">
-            <a:avLst/>
-          </a:prstGeom>
-          <a:solidFill>
-            <a:srgbClr val="095292"/>
-          </a:solidFill>
-          <a:ln>
-            <a:noFill/>
-          </a:ln>
-        </p:spPr>
-        <p:style>
-          <a:lnRef idx="1">
-            <a:schemeClr val="accent1"/>
-          </a:lnRef>
-          <a:fillRef idx="3">
-            <a:schemeClr val="accent1"/>
-          </a:fillRef>
-          <a:effectRef idx="2">
-            <a:schemeClr val="accent1"/>
-          </a:effectRef>
-          <a:fontRef idx="minor">
-            <a:schemeClr val="lt1"/>
-          </a:fontRef>
-        </p:style>
-        <p:txBody>
-          <a:bodyPr rtlCol="0" anchor="ctr"/>
-          <a:lstStyle/>
-          <a:p>
-            <a:pPr algn="ctr"/>
-          </a:p>
-        </p:txBody>
-      </p:sp>
-      <p:sp>
-        <p:nvSpPr>
-          <p:cNvPr id="23" name="Rectangle 22"/>
-          <p:cNvSpPr/>
-          <p:nvPr/>
-        </p:nvSpPr>
-        <p:spPr>
-          <a:xfrm>
-            <a:off x="2370277" y="4119372"/>
-            <a:ext cx="3624986" cy="27432"/>
-          </a:xfrm>
-          <a:prstGeom prst="rect">
-            <a:avLst/>
-          </a:prstGeom>
-          <a:solidFill>
-            <a:srgbClr val="FFD000"/>
-          </a:solidFill>
-          <a:ln>
-            <a:noFill/>
-          </a:ln>
-        </p:spPr>
-        <p:style>
-          <a:lnRef idx="1">
-            <a:schemeClr val="accent1"/>
-          </a:lnRef>
-          <a:fillRef idx="3">
-            <a:schemeClr val="accent1"/>
-          </a:fillRef>
-          <a:effectRef idx="2">
-            <a:schemeClr val="accent1"/>
-          </a:effectRef>
-          <a:fontRef idx="minor">
-            <a:schemeClr val="lt1"/>
-          </a:fontRef>
-        </p:style>
-        <p:txBody>
-          <a:bodyPr rtlCol="0" anchor="ctr"/>
-          <a:lstStyle/>
-          <a:p>
-            <a:pPr algn="ctr"/>
-          </a:p>
-        </p:txBody>
-      </p:sp>
-      <p:pic>
-        <p:nvPicPr>
-          <p:cNvPr id="24" name="Picture 23" descr="sqltest.png"/>
-          <p:cNvPicPr>
-            <a:picLocks noChangeAspect="1"/>
-          </p:cNvPicPr>
-          <p:nvPr/>
-        </p:nvPicPr>
-        <p:blipFill>
-          <a:blip r:embed="rId5"/>
-          <a:stretch>
-            <a:fillRect/>
-          </a:stretch>
-        </p:blipFill>
-        <p:spPr>
-          <a:xfrm>
-            <a:off x="3572408" y="4311396"/>
-            <a:ext cx="1220724" cy="1220724"/>
-          </a:xfrm>
-          <a:prstGeom prst="rect">
-            <a:avLst/>
-          </a:prstGeom>
-        </p:spPr>
-      </p:pic>
-      <p:sp>
-        <p:nvSpPr>
-          <p:cNvPr id="25" name="TextBox 24"/>
-          <p:cNvSpPr txBox="1"/>
-          <p:nvPr/>
-        </p:nvSpPr>
-        <p:spPr>
-          <a:xfrm>
-            <a:off x="2443429" y="5623560"/>
-            <a:ext cx="3478682" cy="621792"/>
-          </a:xfrm>
-          <a:prstGeom prst="rect">
-            <a:avLst/>
-          </a:prstGeom>
-          <a:noFill/>
-        </p:spPr>
-        <p:txBody>
-          <a:bodyPr wrap="square" anchor="t"/>
-          <a:lstStyle/>
-          <a:p>
-            <a:pPr algn="ctr"/>
-            <a:r>
-              <a:rPr sz="1300" b="1" i="0">
-                <a:solidFill>
-                  <a:srgbClr val="095292"/>
-                </a:solidFill>
-                <a:latin typeface="Calibri"/>
-              </a:rPr>
-              <a:t>SQLTest.online</a:t>
-            </a:r>
-          </a:p>
-          <a:p>
-            <a:pPr algn="ctr">
-              <a:spcBef>
-                <a:spcPts val="200"/>
-              </a:spcBef>
-            </a:pPr>
-            <a:r>
-              <a:rPr sz="1000" b="0" i="0">
-                <a:solidFill>
-                  <a:srgbClr val="666666"/>
-                </a:solidFill>
-                <a:latin typeface="Calibri"/>
-              </a:rPr>
-              <a:t>Multi-motor</a:t>
-            </a:r>
-          </a:p>
-        </p:txBody>
-      </p:sp>
-      <p:sp>
-        <p:nvSpPr>
-          <p:cNvPr id="26" name="Rounded Rectangle 25"/>
-          <p:cNvSpPr/>
-          <p:nvPr/>
-        </p:nvSpPr>
-        <p:spPr>
-          <a:xfrm>
-            <a:off x="6196431" y="4055364"/>
-            <a:ext cx="3624986" cy="2299716"/>
-          </a:xfrm>
-          <a:prstGeom prst="roundRect">
-            <a:avLst>
-              <a:gd name="adj" fmla="val 12000"/>
-            </a:avLst>
-          </a:prstGeom>
-          <a:solidFill>
-            <a:srgbClr val="F2F2F2"/>
-          </a:solidFill>
-          <a:ln>
-            <a:noFill/>
-          </a:ln>
-        </p:spPr>
-        <p:style>
-          <a:lnRef idx="1">
-            <a:schemeClr val="accent1"/>
-          </a:lnRef>
-          <a:fillRef idx="3">
-            <a:schemeClr val="accent1"/>
-          </a:fillRef>
-          <a:effectRef idx="2">
-            <a:schemeClr val="accent1"/>
-          </a:effectRef>
-          <a:fontRef idx="minor">
-            <a:schemeClr val="lt1"/>
-          </a:fontRef>
-        </p:style>
-        <p:txBody>
-          <a:bodyPr rtlCol="0" anchor="ctr"/>
-          <a:lstStyle/>
-          <a:p>
-            <a:pPr algn="ctr"/>
-          </a:p>
-        </p:txBody>
-      </p:sp>
-      <p:sp>
-        <p:nvSpPr>
-          <p:cNvPr id="27" name="Rectangle 26"/>
-          <p:cNvSpPr/>
-          <p:nvPr/>
-        </p:nvSpPr>
-        <p:spPr>
-          <a:xfrm>
-            <a:off x="6196431" y="4055364"/>
-            <a:ext cx="3624986" cy="64008"/>
-          </a:xfrm>
-          <a:prstGeom prst="rect">
-            <a:avLst/>
-          </a:prstGeom>
-          <a:solidFill>
-            <a:srgbClr val="095292"/>
-          </a:solidFill>
-          <a:ln>
-            <a:noFill/>
-          </a:ln>
-        </p:spPr>
-        <p:style>
-          <a:lnRef idx="1">
-            <a:schemeClr val="accent1"/>
-          </a:lnRef>
-          <a:fillRef idx="3">
-            <a:schemeClr val="accent1"/>
-          </a:fillRef>
-          <a:effectRef idx="2">
-            <a:schemeClr val="accent1"/>
-          </a:effectRef>
-          <a:fontRef idx="minor">
-            <a:schemeClr val="lt1"/>
-          </a:fontRef>
-        </p:style>
-        <p:txBody>
-          <a:bodyPr rtlCol="0" anchor="ctr"/>
-          <a:lstStyle/>
-          <a:p>
-            <a:pPr algn="ctr"/>
-          </a:p>
-        </p:txBody>
-      </p:sp>
-      <p:sp>
-        <p:nvSpPr>
-          <p:cNvPr id="28" name="Rectangle 27"/>
-          <p:cNvSpPr/>
-          <p:nvPr/>
-        </p:nvSpPr>
-        <p:spPr>
-          <a:xfrm>
-            <a:off x="6196431" y="4119372"/>
-            <a:ext cx="3624986" cy="27432"/>
-          </a:xfrm>
-          <a:prstGeom prst="rect">
-            <a:avLst/>
-          </a:prstGeom>
-          <a:solidFill>
-            <a:srgbClr val="FFD000"/>
-          </a:solidFill>
-          <a:ln>
-            <a:noFill/>
-          </a:ln>
-        </p:spPr>
-        <p:style>
-          <a:lnRef idx="1">
-            <a:schemeClr val="accent1"/>
-          </a:lnRef>
-          <a:fillRef idx="3">
-            <a:schemeClr val="accent1"/>
-          </a:fillRef>
-          <a:effectRef idx="2">
-            <a:schemeClr val="accent1"/>
-          </a:effectRef>
-          <a:fontRef idx="minor">
-            <a:schemeClr val="lt1"/>
-          </a:fontRef>
-        </p:style>
-        <p:txBody>
-          <a:bodyPr rtlCol="0" anchor="ctr"/>
-          <a:lstStyle/>
-          <a:p>
-            <a:pPr algn="ctr"/>
-          </a:p>
-        </p:txBody>
-      </p:sp>
-      <p:pic>
-        <p:nvPicPr>
-          <p:cNvPr id="29" name="Picture 28" descr="examlab.png"/>
-          <p:cNvPicPr>
-            <a:picLocks noChangeAspect="1"/>
-          </p:cNvPicPr>
-          <p:nvPr/>
-        </p:nvPicPr>
-        <p:blipFill>
-          <a:blip r:embed="rId6"/>
-          <a:stretch>
-            <a:fillRect/>
-          </a:stretch>
-        </p:blipFill>
-        <p:spPr>
-          <a:xfrm>
-            <a:off x="7398562" y="4311396"/>
-            <a:ext cx="1220724" cy="1220724"/>
-          </a:xfrm>
-          <a:prstGeom prst="rect">
-            <a:avLst/>
-          </a:prstGeom>
-        </p:spPr>
-      </p:pic>
-      <p:sp>
-        <p:nvSpPr>
-          <p:cNvPr id="30" name="TextBox 29"/>
-          <p:cNvSpPr txBox="1"/>
-          <p:nvPr/>
-        </p:nvSpPr>
-        <p:spPr>
-          <a:xfrm>
-            <a:off x="6269583" y="5623560"/>
-            <a:ext cx="3478682" cy="621792"/>
-          </a:xfrm>
-          <a:prstGeom prst="rect">
-            <a:avLst/>
-          </a:prstGeom>
-          <a:noFill/>
-        </p:spPr>
-        <p:txBody>
-          <a:bodyPr wrap="square" anchor="t"/>
-          <a:lstStyle/>
-          <a:p>
-            <a:pPr algn="ctr"/>
-            <a:r>
-              <a:rPr sz="1300" b="1" i="0">
-                <a:solidFill>
-                  <a:srgbClr val="095292"/>
-                </a:solidFill>
-                <a:latin typeface="Calibri"/>
-              </a:rPr>
-              <a:t>ExamLab</a:t>
-            </a:r>
-          </a:p>
-          <a:p>
-            <a:pPr algn="ctr">
-              <a:spcBef>
-                <a:spcPts val="200"/>
-              </a:spcBef>
-            </a:pPr>
-            <a:r>
-              <a:rPr sz="1000" b="0" i="0">
-                <a:solidFill>
-                  <a:srgbClr val="666666"/>
-                </a:solidFill>
-                <a:latin typeface="Calibri"/>
-              </a:rPr>
-              <a:t>Talleres + quices/parciales</a:t>
-            </a:r>
-          </a:p>
-        </p:txBody>
-      </p:sp>
-      <p:sp>
-        <p:nvSpPr>
-          <p:cNvPr id="31" name="TextBox 30"/>
+              <a:rPr sz="1400" b="0" i="0">
+                <a:solidFill>
+                  <a:srgbClr val="333333"/>
+                </a:solidFill>
+                <a:latin typeface="Calibri"/>
+              </a:rPr>
+              <a:t>Parciales NUNCA en autonoma: P1=sesión 5 (21/09), P2=sesión 9 (19/10), P3=sesión 12 (09/11). La sesión 13 (16/11) es de sustentación del PI VetCare.</a:t>
+            </a:r>
+          </a:p>
+        </p:txBody>
+      </p:sp>
+      <p:sp>
+        <p:nvSpPr>
+          <p:cNvPr id="14" name="TextBox 13"/>
           <p:cNvSpPr txBox="1"/>
           <p:nvPr/>
         </p:nvSpPr>
@@ -6161,6 +5371,1241 @@
         <p:spPr>
           <a:xfrm>
             <a:off x="0" y="0"/>
+            <a:ext cx="12191695" cy="1170432"/>
+          </a:xfrm>
+          <a:prstGeom prst="rect">
+            <a:avLst/>
+          </a:prstGeom>
+          <a:solidFill>
+            <a:srgbClr val="095292"/>
+          </a:solidFill>
+          <a:ln>
+            <a:noFill/>
+          </a:ln>
+        </p:spPr>
+        <p:style>
+          <a:lnRef idx="1">
+            <a:schemeClr val="accent1"/>
+          </a:lnRef>
+          <a:fillRef idx="3">
+            <a:schemeClr val="accent1"/>
+          </a:fillRef>
+          <a:effectRef idx="2">
+            <a:schemeClr val="accent1"/>
+          </a:effectRef>
+          <a:fontRef idx="minor">
+            <a:schemeClr val="lt1"/>
+          </a:fontRef>
+        </p:style>
+        <p:txBody>
+          <a:bodyPr rtlCol="0" anchor="ctr"/>
+          <a:lstStyle/>
+          <a:p>
+            <a:pPr algn="ctr"/>
+          </a:p>
+        </p:txBody>
+      </p:sp>
+      <p:sp>
+        <p:nvSpPr>
+          <p:cNvPr id="3" name="Rectangle 2"/>
+          <p:cNvSpPr/>
+          <p:nvPr/>
+        </p:nvSpPr>
+        <p:spPr>
+          <a:xfrm>
+            <a:off x="0" y="1170432"/>
+            <a:ext cx="12191695" cy="41148"/>
+          </a:xfrm>
+          <a:prstGeom prst="rect">
+            <a:avLst/>
+          </a:prstGeom>
+          <a:solidFill>
+            <a:srgbClr val="FFD000"/>
+          </a:solidFill>
+          <a:ln>
+            <a:noFill/>
+          </a:ln>
+        </p:spPr>
+        <p:style>
+          <a:lnRef idx="1">
+            <a:schemeClr val="accent1"/>
+          </a:lnRef>
+          <a:fillRef idx="3">
+            <a:schemeClr val="accent1"/>
+          </a:fillRef>
+          <a:effectRef idx="2">
+            <a:schemeClr val="accent1"/>
+          </a:effectRef>
+          <a:fontRef idx="minor">
+            <a:schemeClr val="lt1"/>
+          </a:fontRef>
+        </p:style>
+        <p:txBody>
+          <a:bodyPr rtlCol="0" anchor="ctr"/>
+          <a:lstStyle/>
+          <a:p>
+            <a:pPr algn="ctr"/>
+          </a:p>
+        </p:txBody>
+      </p:sp>
+      <p:sp>
+        <p:nvSpPr>
+          <p:cNvPr id="4" name="TextBox 3"/>
+          <p:cNvSpPr txBox="1"/>
+          <p:nvPr/>
+        </p:nvSpPr>
+        <p:spPr>
+          <a:xfrm>
+            <a:off x="457200" y="164592"/>
+            <a:ext cx="11277295" cy="384048"/>
+          </a:xfrm>
+          <a:prstGeom prst="rect">
+            <a:avLst/>
+          </a:prstGeom>
+          <a:noFill/>
+        </p:spPr>
+        <p:txBody>
+          <a:bodyPr wrap="square">
+            <a:spAutoFit/>
+          </a:bodyPr>
+          <a:lstStyle/>
+          <a:p>
+            <a:r>
+              <a:rPr sz="2600" b="1" i="0">
+                <a:solidFill>
+                  <a:srgbClr val="FFFFFF"/>
+                </a:solidFill>
+                <a:latin typeface="Calibri"/>
+              </a:rPr>
+              <a:t>Herramientas del curso</a:t>
+            </a:r>
+          </a:p>
+        </p:txBody>
+      </p:sp>
+      <p:sp>
+        <p:nvSpPr>
+          <p:cNvPr id="5" name="TextBox 4"/>
+          <p:cNvSpPr txBox="1"/>
+          <p:nvPr/>
+        </p:nvSpPr>
+        <p:spPr>
+          <a:xfrm>
+            <a:off x="457200" y="566928"/>
+            <a:ext cx="11277295" cy="411480"/>
+          </a:xfrm>
+          <a:prstGeom prst="rect">
+            <a:avLst/>
+          </a:prstGeom>
+          <a:noFill/>
+        </p:spPr>
+        <p:txBody>
+          <a:bodyPr wrap="square">
+            <a:spAutoFit/>
+          </a:bodyPr>
+          <a:lstStyle/>
+          <a:p>
+            <a:r>
+              <a:rPr sz="1400" b="0" i="0">
+                <a:solidFill>
+                  <a:srgbClr val="B8D8EE"/>
+                </a:solidFill>
+                <a:latin typeface="Calibri"/>
+              </a:rPr>
+              <a:t>Gratis en navegador · SQL + diagramas ER + entrega/evaluación</a:t>
+            </a:r>
+          </a:p>
+        </p:txBody>
+      </p:sp>
+      <p:sp>
+        <p:nvSpPr>
+          <p:cNvPr id="6" name="Rounded Rectangle 5"/>
+          <p:cNvSpPr/>
+          <p:nvPr/>
+        </p:nvSpPr>
+        <p:spPr>
+          <a:xfrm>
+            <a:off x="457200" y="1591056"/>
+            <a:ext cx="3624986" cy="2299716"/>
+          </a:xfrm>
+          <a:prstGeom prst="roundRect">
+            <a:avLst>
+              <a:gd name="adj" fmla="val 12000"/>
+            </a:avLst>
+          </a:prstGeom>
+          <a:solidFill>
+            <a:srgbClr val="F2F2F2"/>
+          </a:solidFill>
+          <a:ln>
+            <a:noFill/>
+          </a:ln>
+        </p:spPr>
+        <p:style>
+          <a:lnRef idx="1">
+            <a:schemeClr val="accent1"/>
+          </a:lnRef>
+          <a:fillRef idx="3">
+            <a:schemeClr val="accent1"/>
+          </a:fillRef>
+          <a:effectRef idx="2">
+            <a:schemeClr val="accent1"/>
+          </a:effectRef>
+          <a:fontRef idx="minor">
+            <a:schemeClr val="lt1"/>
+          </a:fontRef>
+        </p:style>
+        <p:txBody>
+          <a:bodyPr rtlCol="0" anchor="ctr"/>
+          <a:lstStyle/>
+          <a:p>
+            <a:pPr algn="ctr"/>
+          </a:p>
+        </p:txBody>
+      </p:sp>
+      <p:sp>
+        <p:nvSpPr>
+          <p:cNvPr id="7" name="Rectangle 6"/>
+          <p:cNvSpPr/>
+          <p:nvPr/>
+        </p:nvSpPr>
+        <p:spPr>
+          <a:xfrm>
+            <a:off x="457200" y="1591056"/>
+            <a:ext cx="3624986" cy="64008"/>
+          </a:xfrm>
+          <a:prstGeom prst="rect">
+            <a:avLst/>
+          </a:prstGeom>
+          <a:solidFill>
+            <a:srgbClr val="095292"/>
+          </a:solidFill>
+          <a:ln>
+            <a:noFill/>
+          </a:ln>
+        </p:spPr>
+        <p:style>
+          <a:lnRef idx="1">
+            <a:schemeClr val="accent1"/>
+          </a:lnRef>
+          <a:fillRef idx="3">
+            <a:schemeClr val="accent1"/>
+          </a:fillRef>
+          <a:effectRef idx="2">
+            <a:schemeClr val="accent1"/>
+          </a:effectRef>
+          <a:fontRef idx="minor">
+            <a:schemeClr val="lt1"/>
+          </a:fontRef>
+        </p:style>
+        <p:txBody>
+          <a:bodyPr rtlCol="0" anchor="ctr"/>
+          <a:lstStyle/>
+          <a:p>
+            <a:pPr algn="ctr"/>
+          </a:p>
+        </p:txBody>
+      </p:sp>
+      <p:sp>
+        <p:nvSpPr>
+          <p:cNvPr id="8" name="Rectangle 7"/>
+          <p:cNvSpPr/>
+          <p:nvPr/>
+        </p:nvSpPr>
+        <p:spPr>
+          <a:xfrm>
+            <a:off x="457200" y="1655064"/>
+            <a:ext cx="3624986" cy="27432"/>
+          </a:xfrm>
+          <a:prstGeom prst="rect">
+            <a:avLst/>
+          </a:prstGeom>
+          <a:solidFill>
+            <a:srgbClr val="FFD000"/>
+          </a:solidFill>
+          <a:ln>
+            <a:noFill/>
+          </a:ln>
+        </p:spPr>
+        <p:style>
+          <a:lnRef idx="1">
+            <a:schemeClr val="accent1"/>
+          </a:lnRef>
+          <a:fillRef idx="3">
+            <a:schemeClr val="accent1"/>
+          </a:fillRef>
+          <a:effectRef idx="2">
+            <a:schemeClr val="accent1"/>
+          </a:effectRef>
+          <a:fontRef idx="minor">
+            <a:schemeClr val="lt1"/>
+          </a:fontRef>
+        </p:style>
+        <p:txBody>
+          <a:bodyPr rtlCol="0" anchor="ctr"/>
+          <a:lstStyle/>
+          <a:p>
+            <a:pPr algn="ctr"/>
+          </a:p>
+        </p:txBody>
+      </p:sp>
+      <p:pic>
+        <p:nvPicPr>
+          <p:cNvPr id="9" name="Picture 8" descr="dbfiddle.png"/>
+          <p:cNvPicPr>
+            <a:picLocks noChangeAspect="1"/>
+          </p:cNvPicPr>
+          <p:nvPr/>
+        </p:nvPicPr>
+        <p:blipFill>
+          <a:blip r:embed="rId2"/>
+          <a:stretch>
+            <a:fillRect/>
+          </a:stretch>
+        </p:blipFill>
+        <p:spPr>
+          <a:xfrm>
+            <a:off x="1659331" y="1847087"/>
+            <a:ext cx="1220724" cy="1220724"/>
+          </a:xfrm>
+          <a:prstGeom prst="rect">
+            <a:avLst/>
+          </a:prstGeom>
+        </p:spPr>
+      </p:pic>
+      <p:sp>
+        <p:nvSpPr>
+          <p:cNvPr id="10" name="TextBox 9"/>
+          <p:cNvSpPr txBox="1"/>
+          <p:nvPr/>
+        </p:nvSpPr>
+        <p:spPr>
+          <a:xfrm>
+            <a:off x="530352" y="3159251"/>
+            <a:ext cx="3478682" cy="621792"/>
+          </a:xfrm>
+          <a:prstGeom prst="rect">
+            <a:avLst/>
+          </a:prstGeom>
+          <a:noFill/>
+        </p:spPr>
+        <p:txBody>
+          <a:bodyPr wrap="square" anchor="t"/>
+          <a:lstStyle/>
+          <a:p>
+            <a:pPr algn="ctr"/>
+            <a:r>
+              <a:rPr sz="1300" b="1" i="0">
+                <a:solidFill>
+                  <a:srgbClr val="095292"/>
+                </a:solidFill>
+                <a:latin typeface="Calibri"/>
+              </a:rPr>
+              <a:t>DB Fiddle</a:t>
+            </a:r>
+          </a:p>
+          <a:p>
+            <a:pPr algn="ctr">
+              <a:spcBef>
+                <a:spcPts val="200"/>
+              </a:spcBef>
+            </a:pPr>
+            <a:r>
+              <a:rPr sz="1000" b="0" i="0">
+                <a:solidFill>
+                  <a:srgbClr val="666666"/>
+                </a:solidFill>
+                <a:latin typeface="Calibri"/>
+              </a:rPr>
+              <a:t>SQL práctico</a:t>
+            </a:r>
+          </a:p>
+        </p:txBody>
+      </p:sp>
+      <p:sp>
+        <p:nvSpPr>
+          <p:cNvPr id="11" name="Rounded Rectangle 10"/>
+          <p:cNvSpPr/>
+          <p:nvPr/>
+        </p:nvSpPr>
+        <p:spPr>
+          <a:xfrm>
+            <a:off x="4283354" y="1591056"/>
+            <a:ext cx="3624986" cy="2299716"/>
+          </a:xfrm>
+          <a:prstGeom prst="roundRect">
+            <a:avLst>
+              <a:gd name="adj" fmla="val 12000"/>
+            </a:avLst>
+          </a:prstGeom>
+          <a:solidFill>
+            <a:srgbClr val="F2F2F2"/>
+          </a:solidFill>
+          <a:ln>
+            <a:noFill/>
+          </a:ln>
+        </p:spPr>
+        <p:style>
+          <a:lnRef idx="1">
+            <a:schemeClr val="accent1"/>
+          </a:lnRef>
+          <a:fillRef idx="3">
+            <a:schemeClr val="accent1"/>
+          </a:fillRef>
+          <a:effectRef idx="2">
+            <a:schemeClr val="accent1"/>
+          </a:effectRef>
+          <a:fontRef idx="minor">
+            <a:schemeClr val="lt1"/>
+          </a:fontRef>
+        </p:style>
+        <p:txBody>
+          <a:bodyPr rtlCol="0" anchor="ctr"/>
+          <a:lstStyle/>
+          <a:p>
+            <a:pPr algn="ctr"/>
+          </a:p>
+        </p:txBody>
+      </p:sp>
+      <p:sp>
+        <p:nvSpPr>
+          <p:cNvPr id="12" name="Rectangle 11"/>
+          <p:cNvSpPr/>
+          <p:nvPr/>
+        </p:nvSpPr>
+        <p:spPr>
+          <a:xfrm>
+            <a:off x="4283354" y="1591056"/>
+            <a:ext cx="3624986" cy="64008"/>
+          </a:xfrm>
+          <a:prstGeom prst="rect">
+            <a:avLst/>
+          </a:prstGeom>
+          <a:solidFill>
+            <a:srgbClr val="095292"/>
+          </a:solidFill>
+          <a:ln>
+            <a:noFill/>
+          </a:ln>
+        </p:spPr>
+        <p:style>
+          <a:lnRef idx="1">
+            <a:schemeClr val="accent1"/>
+          </a:lnRef>
+          <a:fillRef idx="3">
+            <a:schemeClr val="accent1"/>
+          </a:fillRef>
+          <a:effectRef idx="2">
+            <a:schemeClr val="accent1"/>
+          </a:effectRef>
+          <a:fontRef idx="minor">
+            <a:schemeClr val="lt1"/>
+          </a:fontRef>
+        </p:style>
+        <p:txBody>
+          <a:bodyPr rtlCol="0" anchor="ctr"/>
+          <a:lstStyle/>
+          <a:p>
+            <a:pPr algn="ctr"/>
+          </a:p>
+        </p:txBody>
+      </p:sp>
+      <p:sp>
+        <p:nvSpPr>
+          <p:cNvPr id="13" name="Rectangle 12"/>
+          <p:cNvSpPr/>
+          <p:nvPr/>
+        </p:nvSpPr>
+        <p:spPr>
+          <a:xfrm>
+            <a:off x="4283354" y="1655064"/>
+            <a:ext cx="3624986" cy="27432"/>
+          </a:xfrm>
+          <a:prstGeom prst="rect">
+            <a:avLst/>
+          </a:prstGeom>
+          <a:solidFill>
+            <a:srgbClr val="FFD000"/>
+          </a:solidFill>
+          <a:ln>
+            <a:noFill/>
+          </a:ln>
+        </p:spPr>
+        <p:style>
+          <a:lnRef idx="1">
+            <a:schemeClr val="accent1"/>
+          </a:lnRef>
+          <a:fillRef idx="3">
+            <a:schemeClr val="accent1"/>
+          </a:fillRef>
+          <a:effectRef idx="2">
+            <a:schemeClr val="accent1"/>
+          </a:effectRef>
+          <a:fontRef idx="minor">
+            <a:schemeClr val="lt1"/>
+          </a:fontRef>
+        </p:style>
+        <p:txBody>
+          <a:bodyPr rtlCol="0" anchor="ctr"/>
+          <a:lstStyle/>
+          <a:p>
+            <a:pPr algn="ctr"/>
+          </a:p>
+        </p:txBody>
+      </p:sp>
+      <p:pic>
+        <p:nvPicPr>
+          <p:cNvPr id="14" name="Picture 13" descr="oracle_livesql.png"/>
+          <p:cNvPicPr>
+            <a:picLocks noChangeAspect="1"/>
+          </p:cNvPicPr>
+          <p:nvPr/>
+        </p:nvPicPr>
+        <p:blipFill>
+          <a:blip r:embed="rId3"/>
+          <a:stretch>
+            <a:fillRect/>
+          </a:stretch>
+        </p:blipFill>
+        <p:spPr>
+          <a:xfrm>
+            <a:off x="5485485" y="1847087"/>
+            <a:ext cx="1220724" cy="1220724"/>
+          </a:xfrm>
+          <a:prstGeom prst="rect">
+            <a:avLst/>
+          </a:prstGeom>
+        </p:spPr>
+      </p:pic>
+      <p:sp>
+        <p:nvSpPr>
+          <p:cNvPr id="15" name="TextBox 14"/>
+          <p:cNvSpPr txBox="1"/>
+          <p:nvPr/>
+        </p:nvSpPr>
+        <p:spPr>
+          <a:xfrm>
+            <a:off x="4356506" y="3159251"/>
+            <a:ext cx="3478682" cy="621792"/>
+          </a:xfrm>
+          <a:prstGeom prst="rect">
+            <a:avLst/>
+          </a:prstGeom>
+          <a:noFill/>
+        </p:spPr>
+        <p:txBody>
+          <a:bodyPr wrap="square" anchor="t"/>
+          <a:lstStyle/>
+          <a:p>
+            <a:pPr algn="ctr"/>
+            <a:r>
+              <a:rPr sz="1300" b="1" i="0">
+                <a:solidFill>
+                  <a:srgbClr val="095292"/>
+                </a:solidFill>
+                <a:latin typeface="Calibri"/>
+              </a:rPr>
+              <a:t>Oracle Live SQL</a:t>
+            </a:r>
+          </a:p>
+          <a:p>
+            <a:pPr algn="ctr">
+              <a:spcBef>
+                <a:spcPts val="200"/>
+              </a:spcBef>
+            </a:pPr>
+            <a:r>
+              <a:rPr sz="1000" b="0" i="0">
+                <a:solidFill>
+                  <a:srgbClr val="666666"/>
+                </a:solidFill>
+                <a:latin typeface="Calibri"/>
+              </a:rPr>
+              <a:t>PL/SQL · cuenta free</a:t>
+            </a:r>
+          </a:p>
+        </p:txBody>
+      </p:sp>
+      <p:sp>
+        <p:nvSpPr>
+          <p:cNvPr id="16" name="Rounded Rectangle 15"/>
+          <p:cNvSpPr/>
+          <p:nvPr/>
+        </p:nvSpPr>
+        <p:spPr>
+          <a:xfrm>
+            <a:off x="8109508" y="1591056"/>
+            <a:ext cx="3624986" cy="2299716"/>
+          </a:xfrm>
+          <a:prstGeom prst="roundRect">
+            <a:avLst>
+              <a:gd name="adj" fmla="val 12000"/>
+            </a:avLst>
+          </a:prstGeom>
+          <a:solidFill>
+            <a:srgbClr val="F2F2F2"/>
+          </a:solidFill>
+          <a:ln>
+            <a:noFill/>
+          </a:ln>
+        </p:spPr>
+        <p:style>
+          <a:lnRef idx="1">
+            <a:schemeClr val="accent1"/>
+          </a:lnRef>
+          <a:fillRef idx="3">
+            <a:schemeClr val="accent1"/>
+          </a:fillRef>
+          <a:effectRef idx="2">
+            <a:schemeClr val="accent1"/>
+          </a:effectRef>
+          <a:fontRef idx="minor">
+            <a:schemeClr val="lt1"/>
+          </a:fontRef>
+        </p:style>
+        <p:txBody>
+          <a:bodyPr rtlCol="0" anchor="ctr"/>
+          <a:lstStyle/>
+          <a:p>
+            <a:pPr algn="ctr"/>
+          </a:p>
+        </p:txBody>
+      </p:sp>
+      <p:sp>
+        <p:nvSpPr>
+          <p:cNvPr id="17" name="Rectangle 16"/>
+          <p:cNvSpPr/>
+          <p:nvPr/>
+        </p:nvSpPr>
+        <p:spPr>
+          <a:xfrm>
+            <a:off x="8109508" y="1591056"/>
+            <a:ext cx="3624986" cy="64008"/>
+          </a:xfrm>
+          <a:prstGeom prst="rect">
+            <a:avLst/>
+          </a:prstGeom>
+          <a:solidFill>
+            <a:srgbClr val="095292"/>
+          </a:solidFill>
+          <a:ln>
+            <a:noFill/>
+          </a:ln>
+        </p:spPr>
+        <p:style>
+          <a:lnRef idx="1">
+            <a:schemeClr val="accent1"/>
+          </a:lnRef>
+          <a:fillRef idx="3">
+            <a:schemeClr val="accent1"/>
+          </a:fillRef>
+          <a:effectRef idx="2">
+            <a:schemeClr val="accent1"/>
+          </a:effectRef>
+          <a:fontRef idx="minor">
+            <a:schemeClr val="lt1"/>
+          </a:fontRef>
+        </p:style>
+        <p:txBody>
+          <a:bodyPr rtlCol="0" anchor="ctr"/>
+          <a:lstStyle/>
+          <a:p>
+            <a:pPr algn="ctr"/>
+          </a:p>
+        </p:txBody>
+      </p:sp>
+      <p:sp>
+        <p:nvSpPr>
+          <p:cNvPr id="18" name="Rectangle 17"/>
+          <p:cNvSpPr/>
+          <p:nvPr/>
+        </p:nvSpPr>
+        <p:spPr>
+          <a:xfrm>
+            <a:off x="8109508" y="1655064"/>
+            <a:ext cx="3624986" cy="27432"/>
+          </a:xfrm>
+          <a:prstGeom prst="rect">
+            <a:avLst/>
+          </a:prstGeom>
+          <a:solidFill>
+            <a:srgbClr val="FFD000"/>
+          </a:solidFill>
+          <a:ln>
+            <a:noFill/>
+          </a:ln>
+        </p:spPr>
+        <p:style>
+          <a:lnRef idx="1">
+            <a:schemeClr val="accent1"/>
+          </a:lnRef>
+          <a:fillRef idx="3">
+            <a:schemeClr val="accent1"/>
+          </a:fillRef>
+          <a:effectRef idx="2">
+            <a:schemeClr val="accent1"/>
+          </a:effectRef>
+          <a:fontRef idx="minor">
+            <a:schemeClr val="lt1"/>
+          </a:fontRef>
+        </p:style>
+        <p:txBody>
+          <a:bodyPr rtlCol="0" anchor="ctr"/>
+          <a:lstStyle/>
+          <a:p>
+            <a:pPr algn="ctr"/>
+          </a:p>
+        </p:txBody>
+      </p:sp>
+      <p:pic>
+        <p:nvPicPr>
+          <p:cNvPr id="19" name="Picture 18" descr="drawio.png"/>
+          <p:cNvPicPr>
+            <a:picLocks noChangeAspect="1"/>
+          </p:cNvPicPr>
+          <p:nvPr/>
+        </p:nvPicPr>
+        <p:blipFill>
+          <a:blip r:embed="rId4"/>
+          <a:stretch>
+            <a:fillRect/>
+          </a:stretch>
+        </p:blipFill>
+        <p:spPr>
+          <a:xfrm>
+            <a:off x="9311640" y="1847087"/>
+            <a:ext cx="1220724" cy="1220724"/>
+          </a:xfrm>
+          <a:prstGeom prst="rect">
+            <a:avLst/>
+          </a:prstGeom>
+        </p:spPr>
+      </p:pic>
+      <p:sp>
+        <p:nvSpPr>
+          <p:cNvPr id="20" name="TextBox 19"/>
+          <p:cNvSpPr txBox="1"/>
+          <p:nvPr/>
+        </p:nvSpPr>
+        <p:spPr>
+          <a:xfrm>
+            <a:off x="8182660" y="3159251"/>
+            <a:ext cx="3478682" cy="621792"/>
+          </a:xfrm>
+          <a:prstGeom prst="rect">
+            <a:avLst/>
+          </a:prstGeom>
+          <a:noFill/>
+        </p:spPr>
+        <p:txBody>
+          <a:bodyPr wrap="square" anchor="t"/>
+          <a:lstStyle/>
+          <a:p>
+            <a:pPr algn="ctr"/>
+            <a:r>
+              <a:rPr sz="1300" b="1" i="0">
+                <a:solidFill>
+                  <a:srgbClr val="095292"/>
+                </a:solidFill>
+                <a:latin typeface="Calibri"/>
+              </a:rPr>
+              <a:t>draw.io</a:t>
+            </a:r>
+          </a:p>
+          <a:p>
+            <a:pPr algn="ctr">
+              <a:spcBef>
+                <a:spcPts val="200"/>
+              </a:spcBef>
+            </a:pPr>
+            <a:r>
+              <a:rPr sz="1000" b="0" i="0">
+                <a:solidFill>
+                  <a:srgbClr val="666666"/>
+                </a:solidFill>
+                <a:latin typeface="Calibri"/>
+              </a:rPr>
+              <a:t>Modelos ER</a:t>
+            </a:r>
+          </a:p>
+        </p:txBody>
+      </p:sp>
+      <p:sp>
+        <p:nvSpPr>
+          <p:cNvPr id="21" name="Rounded Rectangle 20"/>
+          <p:cNvSpPr/>
+          <p:nvPr/>
+        </p:nvSpPr>
+        <p:spPr>
+          <a:xfrm>
+            <a:off x="2370277" y="4055364"/>
+            <a:ext cx="3624986" cy="2299716"/>
+          </a:xfrm>
+          <a:prstGeom prst="roundRect">
+            <a:avLst>
+              <a:gd name="adj" fmla="val 12000"/>
+            </a:avLst>
+          </a:prstGeom>
+          <a:solidFill>
+            <a:srgbClr val="F2F2F2"/>
+          </a:solidFill>
+          <a:ln>
+            <a:noFill/>
+          </a:ln>
+        </p:spPr>
+        <p:style>
+          <a:lnRef idx="1">
+            <a:schemeClr val="accent1"/>
+          </a:lnRef>
+          <a:fillRef idx="3">
+            <a:schemeClr val="accent1"/>
+          </a:fillRef>
+          <a:effectRef idx="2">
+            <a:schemeClr val="accent1"/>
+          </a:effectRef>
+          <a:fontRef idx="minor">
+            <a:schemeClr val="lt1"/>
+          </a:fontRef>
+        </p:style>
+        <p:txBody>
+          <a:bodyPr rtlCol="0" anchor="ctr"/>
+          <a:lstStyle/>
+          <a:p>
+            <a:pPr algn="ctr"/>
+          </a:p>
+        </p:txBody>
+      </p:sp>
+      <p:sp>
+        <p:nvSpPr>
+          <p:cNvPr id="22" name="Rectangle 21"/>
+          <p:cNvSpPr/>
+          <p:nvPr/>
+        </p:nvSpPr>
+        <p:spPr>
+          <a:xfrm>
+            <a:off x="2370277" y="4055364"/>
+            <a:ext cx="3624986" cy="64008"/>
+          </a:xfrm>
+          <a:prstGeom prst="rect">
+            <a:avLst/>
+          </a:prstGeom>
+          <a:solidFill>
+            <a:srgbClr val="095292"/>
+          </a:solidFill>
+          <a:ln>
+            <a:noFill/>
+          </a:ln>
+        </p:spPr>
+        <p:style>
+          <a:lnRef idx="1">
+            <a:schemeClr val="accent1"/>
+          </a:lnRef>
+          <a:fillRef idx="3">
+            <a:schemeClr val="accent1"/>
+          </a:fillRef>
+          <a:effectRef idx="2">
+            <a:schemeClr val="accent1"/>
+          </a:effectRef>
+          <a:fontRef idx="minor">
+            <a:schemeClr val="lt1"/>
+          </a:fontRef>
+        </p:style>
+        <p:txBody>
+          <a:bodyPr rtlCol="0" anchor="ctr"/>
+          <a:lstStyle/>
+          <a:p>
+            <a:pPr algn="ctr"/>
+          </a:p>
+        </p:txBody>
+      </p:sp>
+      <p:sp>
+        <p:nvSpPr>
+          <p:cNvPr id="23" name="Rectangle 22"/>
+          <p:cNvSpPr/>
+          <p:nvPr/>
+        </p:nvSpPr>
+        <p:spPr>
+          <a:xfrm>
+            <a:off x="2370277" y="4119372"/>
+            <a:ext cx="3624986" cy="27432"/>
+          </a:xfrm>
+          <a:prstGeom prst="rect">
+            <a:avLst/>
+          </a:prstGeom>
+          <a:solidFill>
+            <a:srgbClr val="FFD000"/>
+          </a:solidFill>
+          <a:ln>
+            <a:noFill/>
+          </a:ln>
+        </p:spPr>
+        <p:style>
+          <a:lnRef idx="1">
+            <a:schemeClr val="accent1"/>
+          </a:lnRef>
+          <a:fillRef idx="3">
+            <a:schemeClr val="accent1"/>
+          </a:fillRef>
+          <a:effectRef idx="2">
+            <a:schemeClr val="accent1"/>
+          </a:effectRef>
+          <a:fontRef idx="minor">
+            <a:schemeClr val="lt1"/>
+          </a:fontRef>
+        </p:style>
+        <p:txBody>
+          <a:bodyPr rtlCol="0" anchor="ctr"/>
+          <a:lstStyle/>
+          <a:p>
+            <a:pPr algn="ctr"/>
+          </a:p>
+        </p:txBody>
+      </p:sp>
+      <p:pic>
+        <p:nvPicPr>
+          <p:cNvPr id="24" name="Picture 23" descr="sqltest.png"/>
+          <p:cNvPicPr>
+            <a:picLocks noChangeAspect="1"/>
+          </p:cNvPicPr>
+          <p:nvPr/>
+        </p:nvPicPr>
+        <p:blipFill>
+          <a:blip r:embed="rId5"/>
+          <a:stretch>
+            <a:fillRect/>
+          </a:stretch>
+        </p:blipFill>
+        <p:spPr>
+          <a:xfrm>
+            <a:off x="3572408" y="4311396"/>
+            <a:ext cx="1220724" cy="1220724"/>
+          </a:xfrm>
+          <a:prstGeom prst="rect">
+            <a:avLst/>
+          </a:prstGeom>
+        </p:spPr>
+      </p:pic>
+      <p:sp>
+        <p:nvSpPr>
+          <p:cNvPr id="25" name="TextBox 24"/>
+          <p:cNvSpPr txBox="1"/>
+          <p:nvPr/>
+        </p:nvSpPr>
+        <p:spPr>
+          <a:xfrm>
+            <a:off x="2443429" y="5623560"/>
+            <a:ext cx="3478682" cy="621792"/>
+          </a:xfrm>
+          <a:prstGeom prst="rect">
+            <a:avLst/>
+          </a:prstGeom>
+          <a:noFill/>
+        </p:spPr>
+        <p:txBody>
+          <a:bodyPr wrap="square" anchor="t"/>
+          <a:lstStyle/>
+          <a:p>
+            <a:pPr algn="ctr"/>
+            <a:r>
+              <a:rPr sz="1300" b="1" i="0">
+                <a:solidFill>
+                  <a:srgbClr val="095292"/>
+                </a:solidFill>
+                <a:latin typeface="Calibri"/>
+              </a:rPr>
+              <a:t>SQLTest.online</a:t>
+            </a:r>
+          </a:p>
+          <a:p>
+            <a:pPr algn="ctr">
+              <a:spcBef>
+                <a:spcPts val="200"/>
+              </a:spcBef>
+            </a:pPr>
+            <a:r>
+              <a:rPr sz="1000" b="0" i="0">
+                <a:solidFill>
+                  <a:srgbClr val="666666"/>
+                </a:solidFill>
+                <a:latin typeface="Calibri"/>
+              </a:rPr>
+              <a:t>Multi-motor</a:t>
+            </a:r>
+          </a:p>
+        </p:txBody>
+      </p:sp>
+      <p:sp>
+        <p:nvSpPr>
+          <p:cNvPr id="26" name="Rounded Rectangle 25"/>
+          <p:cNvSpPr/>
+          <p:nvPr/>
+        </p:nvSpPr>
+        <p:spPr>
+          <a:xfrm>
+            <a:off x="6196431" y="4055364"/>
+            <a:ext cx="3624986" cy="2299716"/>
+          </a:xfrm>
+          <a:prstGeom prst="roundRect">
+            <a:avLst>
+              <a:gd name="adj" fmla="val 12000"/>
+            </a:avLst>
+          </a:prstGeom>
+          <a:solidFill>
+            <a:srgbClr val="F2F2F2"/>
+          </a:solidFill>
+          <a:ln>
+            <a:noFill/>
+          </a:ln>
+        </p:spPr>
+        <p:style>
+          <a:lnRef idx="1">
+            <a:schemeClr val="accent1"/>
+          </a:lnRef>
+          <a:fillRef idx="3">
+            <a:schemeClr val="accent1"/>
+          </a:fillRef>
+          <a:effectRef idx="2">
+            <a:schemeClr val="accent1"/>
+          </a:effectRef>
+          <a:fontRef idx="minor">
+            <a:schemeClr val="lt1"/>
+          </a:fontRef>
+        </p:style>
+        <p:txBody>
+          <a:bodyPr rtlCol="0" anchor="ctr"/>
+          <a:lstStyle/>
+          <a:p>
+            <a:pPr algn="ctr"/>
+          </a:p>
+        </p:txBody>
+      </p:sp>
+      <p:sp>
+        <p:nvSpPr>
+          <p:cNvPr id="27" name="Rectangle 26"/>
+          <p:cNvSpPr/>
+          <p:nvPr/>
+        </p:nvSpPr>
+        <p:spPr>
+          <a:xfrm>
+            <a:off x="6196431" y="4055364"/>
+            <a:ext cx="3624986" cy="64008"/>
+          </a:xfrm>
+          <a:prstGeom prst="rect">
+            <a:avLst/>
+          </a:prstGeom>
+          <a:solidFill>
+            <a:srgbClr val="095292"/>
+          </a:solidFill>
+          <a:ln>
+            <a:noFill/>
+          </a:ln>
+        </p:spPr>
+        <p:style>
+          <a:lnRef idx="1">
+            <a:schemeClr val="accent1"/>
+          </a:lnRef>
+          <a:fillRef idx="3">
+            <a:schemeClr val="accent1"/>
+          </a:fillRef>
+          <a:effectRef idx="2">
+            <a:schemeClr val="accent1"/>
+          </a:effectRef>
+          <a:fontRef idx="minor">
+            <a:schemeClr val="lt1"/>
+          </a:fontRef>
+        </p:style>
+        <p:txBody>
+          <a:bodyPr rtlCol="0" anchor="ctr"/>
+          <a:lstStyle/>
+          <a:p>
+            <a:pPr algn="ctr"/>
+          </a:p>
+        </p:txBody>
+      </p:sp>
+      <p:sp>
+        <p:nvSpPr>
+          <p:cNvPr id="28" name="Rectangle 27"/>
+          <p:cNvSpPr/>
+          <p:nvPr/>
+        </p:nvSpPr>
+        <p:spPr>
+          <a:xfrm>
+            <a:off x="6196431" y="4119372"/>
+            <a:ext cx="3624986" cy="27432"/>
+          </a:xfrm>
+          <a:prstGeom prst="rect">
+            <a:avLst/>
+          </a:prstGeom>
+          <a:solidFill>
+            <a:srgbClr val="FFD000"/>
+          </a:solidFill>
+          <a:ln>
+            <a:noFill/>
+          </a:ln>
+        </p:spPr>
+        <p:style>
+          <a:lnRef idx="1">
+            <a:schemeClr val="accent1"/>
+          </a:lnRef>
+          <a:fillRef idx="3">
+            <a:schemeClr val="accent1"/>
+          </a:fillRef>
+          <a:effectRef idx="2">
+            <a:schemeClr val="accent1"/>
+          </a:effectRef>
+          <a:fontRef idx="minor">
+            <a:schemeClr val="lt1"/>
+          </a:fontRef>
+        </p:style>
+        <p:txBody>
+          <a:bodyPr rtlCol="0" anchor="ctr"/>
+          <a:lstStyle/>
+          <a:p>
+            <a:pPr algn="ctr"/>
+          </a:p>
+        </p:txBody>
+      </p:sp>
+      <p:pic>
+        <p:nvPicPr>
+          <p:cNvPr id="29" name="Picture 28" descr="examlab.png"/>
+          <p:cNvPicPr>
+            <a:picLocks noChangeAspect="1"/>
+          </p:cNvPicPr>
+          <p:nvPr/>
+        </p:nvPicPr>
+        <p:blipFill>
+          <a:blip r:embed="rId6"/>
+          <a:stretch>
+            <a:fillRect/>
+          </a:stretch>
+        </p:blipFill>
+        <p:spPr>
+          <a:xfrm>
+            <a:off x="7398562" y="4311396"/>
+            <a:ext cx="1220724" cy="1220724"/>
+          </a:xfrm>
+          <a:prstGeom prst="rect">
+            <a:avLst/>
+          </a:prstGeom>
+        </p:spPr>
+      </p:pic>
+      <p:sp>
+        <p:nvSpPr>
+          <p:cNvPr id="30" name="TextBox 29"/>
+          <p:cNvSpPr txBox="1"/>
+          <p:nvPr/>
+        </p:nvSpPr>
+        <p:spPr>
+          <a:xfrm>
+            <a:off x="6269583" y="5623560"/>
+            <a:ext cx="3478682" cy="621792"/>
+          </a:xfrm>
+          <a:prstGeom prst="rect">
+            <a:avLst/>
+          </a:prstGeom>
+          <a:noFill/>
+        </p:spPr>
+        <p:txBody>
+          <a:bodyPr wrap="square" anchor="t"/>
+          <a:lstStyle/>
+          <a:p>
+            <a:pPr algn="ctr"/>
+            <a:r>
+              <a:rPr sz="1300" b="1" i="0">
+                <a:solidFill>
+                  <a:srgbClr val="095292"/>
+                </a:solidFill>
+                <a:latin typeface="Calibri"/>
+              </a:rPr>
+              <a:t>ExamLab</a:t>
+            </a:r>
+          </a:p>
+          <a:p>
+            <a:pPr algn="ctr">
+              <a:spcBef>
+                <a:spcPts val="200"/>
+              </a:spcBef>
+            </a:pPr>
+            <a:r>
+              <a:rPr sz="1000" b="0" i="0">
+                <a:solidFill>
+                  <a:srgbClr val="666666"/>
+                </a:solidFill>
+                <a:latin typeface="Calibri"/>
+              </a:rPr>
+              <a:t>Talleres + quices/parciales</a:t>
+            </a:r>
+          </a:p>
+        </p:txBody>
+      </p:sp>
+      <p:sp>
+        <p:nvSpPr>
+          <p:cNvPr id="31" name="TextBox 30"/>
+          <p:cNvSpPr txBox="1"/>
+          <p:nvPr/>
+        </p:nvSpPr>
+        <p:spPr>
+          <a:xfrm>
+            <a:off x="11185855" y="6473952"/>
+            <a:ext cx="640080" cy="274320"/>
+          </a:xfrm>
+          <a:prstGeom prst="rect">
+            <a:avLst/>
+          </a:prstGeom>
+          <a:noFill/>
+        </p:spPr>
+        <p:txBody>
+          <a:bodyPr wrap="square">
+            <a:spAutoFit/>
+          </a:bodyPr>
+          <a:lstStyle/>
+          <a:p>
+            <a:pPr algn="r"/>
+            <a:r>
+              <a:rPr sz="1100" b="0" i="0">
+                <a:solidFill>
+                  <a:srgbClr val="666666"/>
+                </a:solidFill>
+                <a:latin typeface="Calibri"/>
+              </a:rPr>
+              <a:t>13</a:t>
+            </a:r>
+          </a:p>
+        </p:txBody>
+      </p:sp>
+    </p:spTree>
+  </p:cSld>
+  <p:clrMapOvr>
+    <a:masterClrMapping/>
+  </p:clrMapOvr>
+</p:sld>
+</file>
+
+<file path=ppt/slides/slide15.xml><?xml version="1.0" encoding="utf-8"?>
+<p:sld xmlns:a="http://schemas.openxmlformats.org/drawingml/2006/main" xmlns:p="http://schemas.openxmlformats.org/presentationml/2006/main" xmlns:r="http://schemas.openxmlformats.org/officeDocument/2006/relationships">
+  <p:cSld>
+    <p:bg>
+      <p:bgPr>
+        <a:solidFill>
+          <a:srgbClr val="FFFFFF"/>
+        </a:solidFill>
+        <a:effectLst/>
+      </p:bgPr>
+    </p:bg>
+    <p:spTree>
+      <p:nvGrpSpPr>
+        <p:cNvPr id="1" name=""/>
+        <p:cNvGrpSpPr/>
+        <p:nvPr/>
+      </p:nvGrpSpPr>
+      <p:grpSpPr/>
+      <p:sp>
+        <p:nvSpPr>
+          <p:cNvPr id="2" name="Rectangle 1"/>
+          <p:cNvSpPr/>
+          <p:nvPr/>
+        </p:nvSpPr>
+        <p:spPr>
+          <a:xfrm>
+            <a:off x="0" y="0"/>
             <a:ext cx="12191695" cy="164592"/>
           </a:xfrm>
           <a:prstGeom prst="rect">
@@ -8610,7 +9055,7 @@
                 </a:solidFill>
                 <a:latin typeface="Calibri"/>
               </a:rPr>
-              <a:t>: sesión 1 y parciales (</a:t>
+              <a:t>, todas </a:t>
             </a:r>
             <a:r>
               <a:rPr sz="1600" b="1" i="0">
@@ -8619,6 +9064,24 @@
                 </a:solidFill>
                 <a:latin typeface="Calibri"/>
               </a:rPr>
+              <a:t>virtuales síncronas por Meet</a:t>
+            </a:r>
+            <a:r>
+              <a:rPr sz="1600" b="0" i="0">
+                <a:solidFill>
+                  <a:srgbClr val="333333"/>
+                </a:solidFill>
+                <a:latin typeface="Calibri"/>
+              </a:rPr>
+              <a:t> — incluidos los parciales (</a:t>
+            </a:r>
+            <a:r>
+              <a:rPr sz="1600" b="1" i="0">
+                <a:solidFill>
+                  <a:srgbClr val="333333"/>
+                </a:solidFill>
+                <a:latin typeface="Calibri"/>
+              </a:rPr>
               <a:t>5 / 9 / 12</a:t>
             </a:r>
             <a:r>
@@ -8628,43 +9091,7 @@
                 </a:solidFill>
                 <a:latin typeface="Calibri"/>
               </a:rPr>
-              <a:t>) </a:t>
-            </a:r>
-            <a:r>
-              <a:rPr sz="1600" b="1" i="0">
-                <a:solidFill>
-                  <a:srgbClr val="333333"/>
-                </a:solidFill>
-                <a:latin typeface="Calibri"/>
-              </a:rPr>
-              <a:t>presencial</a:t>
-            </a:r>
-            <a:r>
-              <a:rPr sz="1600" b="0" i="0">
-                <a:solidFill>
-                  <a:srgbClr val="333333"/>
-                </a:solidFill>
-                <a:latin typeface="Calibri"/>
-              </a:rPr>
-              <a:t>; resto </a:t>
-            </a:r>
-            <a:r>
-              <a:rPr sz="1600" b="1" i="0">
-                <a:solidFill>
-                  <a:srgbClr val="333333"/>
-                </a:solidFill>
-                <a:latin typeface="Calibri"/>
-              </a:rPr>
-              <a:t>virtual síncrona</a:t>
-            </a:r>
-            <a:r>
-              <a:rPr sz="1600" b="0" i="0">
-                <a:solidFill>
-                  <a:srgbClr val="333333"/>
-                </a:solidFill>
-                <a:latin typeface="Calibri"/>
-              </a:rPr>
-              <a:t>; festivos = </a:t>
+              <a:t>); festivos = </a:t>
             </a:r>
             <a:r>
               <a:rPr sz="1600" b="1" i="0">
@@ -9877,7 +10304,7 @@
                 </a:solidFill>
                 <a:latin typeface="Calibri"/>
               </a:rPr>
-              <a:t>Parciales síncronos presenciales · nunca en festivo/autónoma. Día de parcial = solo evaluación.</a:t>
+              <a:t>Parciales síncronos por Meet · nunca en festivo/autónoma. Día de parcial = solo evaluación.</a:t>
             </a:r>
           </a:p>
         </p:txBody>
@@ -10336,7 +10763,7 @@
                 </a:solidFill>
                 <a:latin typeface="Calibri"/>
               </a:rPr>
-              <a:t> Parcial 1 (21/09) · presencial · solo evaluación</a:t>
+              <a:t> Parcial 1 (21/09) · virtual síncrona · solo evaluación</a:t>
             </a:r>
           </a:p>
           <a:p>
@@ -10495,7 +10922,7 @@
                 </a:solidFill>
                 <a:latin typeface="Calibri"/>
               </a:rPr>
-              <a:t> Parcial 2 (19/10) · presencial · solo evaluación</a:t>
+              <a:t> Parcial 2 (19/10) · virtual síncrona · solo evaluación</a:t>
             </a:r>
           </a:p>
           <a:p>
@@ -10597,7 +11024,7 @@
                 </a:solidFill>
                 <a:latin typeface="Calibri"/>
               </a:rPr>
-              <a:t> Parcial 3 (09/11) · presencial · solo evaluación</a:t>
+              <a:t> Parcial 3 (09/11) · virtual síncrona · solo evaluación</a:t>
             </a:r>
           </a:p>
           <a:p>

</xml_diff>